<commit_message>
Add demo video link; integrate finalized poster and summary form; bundle submission archive
</commit_message>
<xml_diff>
--- a/Project/poster/SOC-Copilot-Poster.pptx
+++ b/Project/poster/SOC-Copilot-Poster.pptx
@@ -4,14 +4,14 @@
   <p:sldMasterIdLst>
     <p:sldMasterId id="2147483648" r:id="rId1"/>
   </p:sldMasterIdLst>
+  <p:notesMasterIdLst>
+    <p:notesMasterId r:id="rId3"/>
+  </p:notesMasterIdLst>
   <p:sldIdLst>
     <p:sldId id="256" r:id="rId2"/>
   </p:sldIdLst>
-  <p:notesMasterIdLst>
-    <p:notesMasterId r:id="rId3"/>
-  </p:notesMasterIdLst>
-  <p:sldSz cx="25199950" cy="35999928"/>
-  <p:notesSz cx="35999928" cy="25199950"/>
+  <p:sldSz cx="25199975" cy="35999738"/>
+  <p:notesSz cx="35999738" cy="25199975"/>
   <p:defaultTextStyle>
     <a:lvl1pPr marL="0" algn="l" defTabSz="914400" rtl="0" eaLnBrk="1" latinLnBrk="0" hangingPunct="1">
       <a:defRPr sz="1800" kern="1200">
@@ -104,6 +104,11 @@
       </a:defRPr>
     </a:lvl9pPr>
   </p:defaultTextStyle>
+  <p:extLst>
+    <p:ext uri="{EFAFB233-063F-42B5-8137-9DF3F51BA10A}">
+      <p15:sldGuideLst xmlns:p15="http://schemas.microsoft.com/office/powerpoint/2012/main"/>
+    </p:ext>
+  </p:extLst>
 </p:presentation>
 </file>
 
@@ -129,240 +134,16 @@
           <a:chExt cx="0" cy="0"/>
         </a:xfrm>
       </p:grpSpPr>
-      <p:sp>
-        <p:nvSpPr>
-          <p:cNvPr id="2" name="Header Placeholder 1"/>
-          <p:cNvSpPr>
-            <a:spLocks noGrp="1"/>
-          </p:cNvSpPr>
-          <p:nvPr>
-            <p:ph type="hdr" sz="quarter"/>
-          </p:nvPr>
-        </p:nvSpPr>
-        <p:spPr>
-          <a:xfrm>
-            <a:off x="0" y="0"/>
-            <a:ext cx="2971800" cy="458788"/>
-          </a:xfrm>
-          <a:prstGeom prst="rect">
-            <a:avLst/>
-          </a:prstGeom>
-        </p:spPr>
-        <p:txBody>
-          <a:bodyPr vert="horz" lIns="91440" tIns="45720" rIns="91440" bIns="45720" rtlCol="0"/>
-          <a:lstStyle>
-            <a:lvl1pPr algn="l">
-              <a:defRPr sz="1200"/>
-            </a:lvl1pPr>
-          </a:lstStyle>
-          <a:p>
-            <a:endParaRPr lang="en-US"/>
-          </a:p>
-        </p:txBody>
-      </p:sp>
-      <p:sp>
-        <p:nvSpPr>
-          <p:cNvPr id="3" name="Date Placeholder 2"/>
-          <p:cNvSpPr>
-            <a:spLocks noGrp="1"/>
-          </p:cNvSpPr>
-          <p:nvPr>
-            <p:ph type="dt" idx="1"/>
-          </p:nvPr>
-        </p:nvSpPr>
-        <p:spPr>
-          <a:xfrm>
-            <a:off x="3884613" y="0"/>
-            <a:ext cx="2971800" cy="458788"/>
-          </a:xfrm>
-          <a:prstGeom prst="rect">
-            <a:avLst/>
-          </a:prstGeom>
-        </p:spPr>
-        <p:txBody>
-          <a:bodyPr vert="horz" lIns="91440" tIns="45720" rIns="91440" bIns="45720" rtlCol="0"/>
-          <a:lstStyle>
-            <a:lvl1pPr algn="r">
-              <a:defRPr sz="1200"/>
-            </a:lvl1pPr>
-          </a:lstStyle>
-          <a:p>
-            <a:fld id="{5282F153-3F37-0F45-9E97-73ACFA13230C}" type="datetimeFigureOut">
-              <a:rPr lang="en-US"/>
-              <a:t>7/23/19</a:t>
-            </a:fld>
-            <a:endParaRPr lang="en-US"/>
-          </a:p>
-        </p:txBody>
-      </p:sp>
-      <p:sp>
-        <p:nvSpPr>
-          <p:cNvPr id="4" name="Slide Image Placeholder 3"/>
-          <p:cNvSpPr>
-            <a:spLocks noGrp="1" noRot="1" noChangeAspect="1"/>
-          </p:cNvSpPr>
-          <p:nvPr>
-            <p:ph type="sldImg" idx="2"/>
-          </p:nvPr>
-        </p:nvSpPr>
-        <p:spPr>
-          <a:xfrm>
-            <a:off x="685800" y="1143000"/>
-            <a:ext cx="5486400" cy="3086100"/>
-          </a:xfrm>
-          <a:prstGeom prst="rect">
-            <a:avLst/>
-          </a:prstGeom>
-          <a:noFill/>
-          <a:ln w="12700">
-            <a:solidFill>
-              <a:prstClr val="black"/>
-            </a:solidFill>
-          </a:ln>
-        </p:spPr>
-        <p:txBody>
-          <a:bodyPr vert="horz" lIns="91440" tIns="45720" rIns="91440" bIns="45720" rtlCol="0" anchor="ctr"/>
-          <a:lstStyle/>
-          <a:p>
-            <a:endParaRPr lang="en-US"/>
-          </a:p>
-        </p:txBody>
-      </p:sp>
-      <p:sp>
-        <p:nvSpPr>
-          <p:cNvPr id="5" name="Notes Placeholder 4"/>
-          <p:cNvSpPr>
-            <a:spLocks noGrp="1"/>
-          </p:cNvSpPr>
-          <p:nvPr>
-            <p:ph type="body" sz="quarter" idx="3"/>
-          </p:nvPr>
-        </p:nvSpPr>
-        <p:spPr>
-          <a:xfrm>
-            <a:off x="685800" y="4400550"/>
-            <a:ext cx="5486400" cy="3600450"/>
-          </a:xfrm>
-          <a:prstGeom prst="rect">
-            <a:avLst/>
-          </a:prstGeom>
-        </p:spPr>
-        <p:txBody>
-          <a:bodyPr vert="horz" lIns="91440" tIns="45720" rIns="91440" bIns="45720" rtlCol="0"/>
-          <a:lstStyle/>
-          <a:p>
-            <a:pPr lvl="0"/>
-            <a:r>
-              <a:rPr lang="en-US"/>
-              <a:t>Click to edit Master text styles</a:t>
-            </a:r>
-          </a:p>
-          <a:p>
-            <a:pPr lvl="1"/>
-            <a:r>
-              <a:rPr lang="en-US"/>
-              <a:t>Second level</a:t>
-            </a:r>
-          </a:p>
-          <a:p>
-            <a:pPr lvl="2"/>
-            <a:r>
-              <a:rPr lang="en-US"/>
-              <a:t>Third level</a:t>
-            </a:r>
-          </a:p>
-          <a:p>
-            <a:pPr lvl="3"/>
-            <a:r>
-              <a:rPr lang="en-US"/>
-              <a:t>Fourth level</a:t>
-            </a:r>
-          </a:p>
-          <a:p>
-            <a:pPr lvl="4"/>
-            <a:r>
-              <a:rPr lang="en-US"/>
-              <a:t>Fifth level</a:t>
-            </a:r>
-          </a:p>
-        </p:txBody>
-      </p:sp>
-      <p:sp>
-        <p:nvSpPr>
-          <p:cNvPr id="6" name="Footer Placeholder 5"/>
-          <p:cNvSpPr>
-            <a:spLocks noGrp="1"/>
-          </p:cNvSpPr>
-          <p:nvPr>
-            <p:ph type="ftr" sz="quarter" idx="4"/>
-          </p:nvPr>
-        </p:nvSpPr>
-        <p:spPr>
-          <a:xfrm>
-            <a:off x="0" y="8685213"/>
-            <a:ext cx="2971800" cy="458787"/>
-          </a:xfrm>
-          <a:prstGeom prst="rect">
-            <a:avLst/>
-          </a:prstGeom>
-        </p:spPr>
-        <p:txBody>
-          <a:bodyPr vert="horz" lIns="91440" tIns="45720" rIns="91440" bIns="45720" rtlCol="0" anchor="b"/>
-          <a:lstStyle>
-            <a:lvl1pPr algn="l">
-              <a:defRPr sz="1200"/>
-            </a:lvl1pPr>
-          </a:lstStyle>
-          <a:p>
-            <a:endParaRPr lang="en-US"/>
-          </a:p>
-        </p:txBody>
-      </p:sp>
-      <p:sp>
-        <p:nvSpPr>
-          <p:cNvPr id="7" name="Slide Number Placeholder 6"/>
-          <p:cNvSpPr>
-            <a:spLocks noGrp="1"/>
-          </p:cNvSpPr>
-          <p:nvPr>
-            <p:ph type="sldNum" sz="quarter" idx="5"/>
-          </p:nvPr>
-        </p:nvSpPr>
-        <p:spPr>
-          <a:xfrm>
-            <a:off x="3884613" y="8685213"/>
-            <a:ext cx="2971800" cy="458787"/>
-          </a:xfrm>
-          <a:prstGeom prst="rect">
-            <a:avLst/>
-          </a:prstGeom>
-        </p:spPr>
-        <p:txBody>
-          <a:bodyPr vert="horz" lIns="91440" tIns="45720" rIns="91440" bIns="45720" rtlCol="0" anchor="b"/>
-          <a:lstStyle>
-            <a:lvl1pPr algn="r">
-              <a:defRPr sz="1200"/>
-            </a:lvl1pPr>
-          </a:lstStyle>
-          <a:p>
-            <a:fld id="{CE5E9CC1-C706-0F49-92D6-E571CC5EEA8F}" type="slidenum">
-              <a:rPr lang="en-US"/>
-              <a:t>‹#›</a:t>
-            </a:fld>
-            <a:endParaRPr lang="en-US"/>
-          </a:p>
-        </p:txBody>
-      </p:sp>
     </p:spTree>
     <p:extLst>
       <p:ext uri="{BB962C8B-B14F-4D97-AF65-F5344CB8AC3E}">
-        <p14:creationId xmlns:p14="http://schemas.microsoft.com/office/powerpoint/2010/main" val="1024086991"/>
+        <p14:creationId xmlns:p14="http://schemas.microsoft.com/office/powerpoint/2010/main" val="3839586267"/>
       </p:ext>
     </p:extLst>
   </p:cSld>
   <p:clrMap bg1="lt1" tx1="dk1" bg2="lt2" tx2="dk2" accent1="accent1" accent2="accent2" accent3="accent3" accent4="accent4" accent5="accent5" accent6="accent6" hlink="hlink" folHlink="folHlink"/>
   <p:notesStyle>
-    <a:lvl1pPr marL="0" algn="l" defTabSz="914400" rtl="0" eaLnBrk="1" latinLnBrk="0" hangingPunct="1">
+    <a:lvl1pPr marL="0" algn="r" defTabSz="914400" rtl="1" eaLnBrk="1" latinLnBrk="0" hangingPunct="1">
       <a:defRPr sz="1200" kern="1200">
         <a:solidFill>
           <a:schemeClr val="tx1"/>
@@ -372,7 +153,7 @@
         <a:cs typeface="+mn-cs"/>
       </a:defRPr>
     </a:lvl1pPr>
-    <a:lvl2pPr marL="457200" algn="l" defTabSz="914400" rtl="0" eaLnBrk="1" latinLnBrk="0" hangingPunct="1">
+    <a:lvl2pPr marL="457200" algn="r" defTabSz="914400" rtl="1" eaLnBrk="1" latinLnBrk="0" hangingPunct="1">
       <a:defRPr sz="1200" kern="1200">
         <a:solidFill>
           <a:schemeClr val="tx1"/>
@@ -382,7 +163,7 @@
         <a:cs typeface="+mn-cs"/>
       </a:defRPr>
     </a:lvl2pPr>
-    <a:lvl3pPr marL="914400" algn="l" defTabSz="914400" rtl="0" eaLnBrk="1" latinLnBrk="0" hangingPunct="1">
+    <a:lvl3pPr marL="914400" algn="r" defTabSz="914400" rtl="1" eaLnBrk="1" latinLnBrk="0" hangingPunct="1">
       <a:defRPr sz="1200" kern="1200">
         <a:solidFill>
           <a:schemeClr val="tx1"/>
@@ -392,7 +173,7 @@
         <a:cs typeface="+mn-cs"/>
       </a:defRPr>
     </a:lvl3pPr>
-    <a:lvl4pPr marL="1371600" algn="l" defTabSz="914400" rtl="0" eaLnBrk="1" latinLnBrk="0" hangingPunct="1">
+    <a:lvl4pPr marL="1371600" algn="r" defTabSz="914400" rtl="1" eaLnBrk="1" latinLnBrk="0" hangingPunct="1">
       <a:defRPr sz="1200" kern="1200">
         <a:solidFill>
           <a:schemeClr val="tx1"/>
@@ -402,7 +183,7 @@
         <a:cs typeface="+mn-cs"/>
       </a:defRPr>
     </a:lvl4pPr>
-    <a:lvl5pPr marL="1828800" algn="l" defTabSz="914400" rtl="0" eaLnBrk="1" latinLnBrk="0" hangingPunct="1">
+    <a:lvl5pPr marL="1828800" algn="r" defTabSz="914400" rtl="1" eaLnBrk="1" latinLnBrk="0" hangingPunct="1">
       <a:defRPr sz="1200" kern="1200">
         <a:solidFill>
           <a:schemeClr val="tx1"/>
@@ -412,7 +193,7 @@
         <a:cs typeface="+mn-cs"/>
       </a:defRPr>
     </a:lvl5pPr>
-    <a:lvl6pPr marL="2286000" algn="l" defTabSz="914400" rtl="0" eaLnBrk="1" latinLnBrk="0" hangingPunct="1">
+    <a:lvl6pPr marL="2286000" algn="r" defTabSz="914400" rtl="1" eaLnBrk="1" latinLnBrk="0" hangingPunct="1">
       <a:defRPr sz="1200" kern="1200">
         <a:solidFill>
           <a:schemeClr val="tx1"/>
@@ -422,7 +203,7 @@
         <a:cs typeface="+mn-cs"/>
       </a:defRPr>
     </a:lvl6pPr>
-    <a:lvl7pPr marL="2743200" algn="l" defTabSz="914400" rtl="0" eaLnBrk="1" latinLnBrk="0" hangingPunct="1">
+    <a:lvl7pPr marL="2743200" algn="r" defTabSz="914400" rtl="1" eaLnBrk="1" latinLnBrk="0" hangingPunct="1">
       <a:defRPr sz="1200" kern="1200">
         <a:solidFill>
           <a:schemeClr val="tx1"/>
@@ -432,7 +213,7 @@
         <a:cs typeface="+mn-cs"/>
       </a:defRPr>
     </a:lvl7pPr>
-    <a:lvl8pPr marL="3200400" algn="l" defTabSz="914400" rtl="0" eaLnBrk="1" latinLnBrk="0" hangingPunct="1">
+    <a:lvl8pPr marL="3200400" algn="r" defTabSz="914400" rtl="1" eaLnBrk="1" latinLnBrk="0" hangingPunct="1">
       <a:defRPr sz="1200" kern="1200">
         <a:solidFill>
           <a:schemeClr val="tx1"/>
@@ -442,7 +223,7 @@
         <a:cs typeface="+mn-cs"/>
       </a:defRPr>
     </a:lvl8pPr>
-    <a:lvl9pPr marL="3657600" algn="l" defTabSz="914400" rtl="0" eaLnBrk="1" latinLnBrk="0" hangingPunct="1">
+    <a:lvl9pPr marL="3657600" algn="r" defTabSz="914400" rtl="1" eaLnBrk="1" latinLnBrk="0" hangingPunct="1">
       <a:defRPr sz="1200" kern="1200">
         <a:solidFill>
           <a:schemeClr val="tx1"/>
@@ -500,10 +281,6 @@
           <a:bodyPr/>
           <a:lstStyle/>
           <a:p>
-            <a:r>
-              <a:rPr lang="en-US" dirty="0"/>
-              <a:t/>
-            </a:r>
             <a:endParaRPr lang="en-US" dirty="0"/>
           </a:p>
         </p:txBody>
@@ -577,6 +354,11 @@
 <file path=ppt/slideMasters/slideMaster1.xml><?xml version="1.0" encoding="utf-8"?>
 <p:sldMaster xmlns:a="http://schemas.openxmlformats.org/drawingml/2006/main" xmlns:r="http://schemas.openxmlformats.org/officeDocument/2006/relationships" xmlns:p="http://schemas.openxmlformats.org/presentationml/2006/main">
   <p:cSld>
+    <p:bg>
+      <p:bgRef idx="1001">
+        <a:schemeClr val="bg1"/>
+      </p:bgRef>
+    </p:bg>
     <p:spTree>
       <p:nvGrpSpPr>
         <p:cNvPr id="1" name=""/>
@@ -859,6 +641,7 @@
         <a:solidFill>
           <a:srgbClr val="F8FAFC"/>
         </a:solidFill>
+        <a:effectLst/>
       </p:bgPr>
     </p:bg>
     <p:spTree>
@@ -899,6 +682,13 @@
             <a:prstDash val="solid"/>
           </a:ln>
         </p:spPr>
+        <p:txBody>
+          <a:bodyPr/>
+          <a:lstStyle/>
+          <a:p>
+            <a:endParaRPr lang="he-IL"/>
+          </a:p>
+        </p:txBody>
       </p:sp>
       <p:sp>
         <p:nvSpPr>
@@ -924,6 +714,13 @@
             <a:prstDash val="solid"/>
           </a:ln>
         </p:spPr>
+        <p:txBody>
+          <a:bodyPr/>
+          <a:lstStyle/>
+          <a:p>
+            <a:endParaRPr lang="he-IL"/>
+          </a:p>
+        </p:txBody>
       </p:sp>
       <p:sp>
         <p:nvSpPr>
@@ -946,11 +743,11 @@
           <a:bodyPr wrap="square" lIns="0" tIns="0" rIns="0" bIns="0" rtlCol="0" anchor="ctr"/>
           <a:lstStyle/>
           <a:p>
-            <a:pPr algn="ctr" indent="0" marL="0">
-              <a:buNone/>
-            </a:pPr>
-            <a:r>
-              <a:rPr lang="en-US" sz="4000" spc="400" kern="0" dirty="0">
+            <a:pPr marL="0" indent="0" algn="ctr">
+              <a:buNone/>
+            </a:pPr>
+            <a:r>
+              <a:rPr lang="en-US" sz="4000" kern="0" spc="400" dirty="0">
                 <a:solidFill>
                   <a:srgbClr val="22D3EE"/>
                 </a:solidFill>
@@ -985,7 +782,7 @@
           <a:bodyPr wrap="square" lIns="0" tIns="0" rIns="0" bIns="0" rtlCol="0" anchor="ctr"/>
           <a:lstStyle/>
           <a:p>
-            <a:pPr algn="ctr" indent="0" marL="0">
+            <a:pPr marL="0" indent="0" algn="ctr">
               <a:buNone/>
             </a:pPr>
             <a:r>
@@ -1024,7 +821,7 @@
           <a:bodyPr wrap="square" lIns="0" tIns="0" rIns="0" bIns="0" rtlCol="0" anchor="ctr"/>
           <a:lstStyle/>
           <a:p>
-            <a:pPr algn="ctr" indent="0" marL="0">
+            <a:pPr marL="0" indent="0" algn="ctr">
               <a:buNone/>
             </a:pPr>
             <a:r>
@@ -1050,7 +847,7 @@
         </p:nvSpPr>
         <p:spPr>
           <a:xfrm>
-            <a:off x="640080" y="3154680"/>
+            <a:off x="640080" y="3036276"/>
             <a:ext cx="11777015" cy="1417320"/>
           </a:xfrm>
           <a:prstGeom prst="rect">
@@ -1063,7 +860,7 @@
           <a:bodyPr wrap="square" lIns="0" tIns="0" rIns="0" bIns="0" rtlCol="0" anchor="t"/>
           <a:lstStyle/>
           <a:p>
-            <a:pPr algn="l" indent="0" marL="0">
+            <a:pPr marL="0" indent="0" algn="l">
               <a:buNone/>
             </a:pPr>
             <a:r>
@@ -1077,9 +874,6 @@
               </a:rPr>
               <a:t>Course:  </a:t>
             </a:r>
-            <a:pPr algn="l" indent="0" marL="0">
-              <a:buNone/>
-            </a:pPr>
             <a:r>
               <a:rPr lang="en-US" sz="4000" b="1" dirty="0">
                 <a:solidFill>
@@ -1094,7 +888,7 @@
             <a:endParaRPr lang="en-US" sz="4000" dirty="0"/>
           </a:p>
           <a:p>
-            <a:pPr algn="l" indent="0" marL="0">
+            <a:pPr marL="0" indent="0" algn="l">
               <a:buNone/>
             </a:pPr>
             <a:r>
@@ -1120,7 +914,7 @@
         </p:nvSpPr>
         <p:spPr>
           <a:xfrm>
-            <a:off x="12782855" y="3154680"/>
+            <a:off x="12782855" y="2944178"/>
             <a:ext cx="11777015" cy="1417320"/>
           </a:xfrm>
           <a:prstGeom prst="rect">
@@ -1133,7 +927,7 @@
           <a:bodyPr wrap="square" lIns="0" tIns="0" rIns="0" bIns="0" rtlCol="0" anchor="t"/>
           <a:lstStyle/>
           <a:p>
-            <a:pPr algn="r" indent="0" marL="0">
+            <a:pPr marL="0" indent="0" algn="r">
               <a:buNone/>
             </a:pPr>
             <a:r>
@@ -1147,9 +941,6 @@
               </a:rPr>
               <a:t>Lecturers:  </a:t>
             </a:r>
-            <a:pPr algn="r" indent="0" marL="0">
-              <a:buNone/>
-            </a:pPr>
             <a:r>
               <a:rPr lang="en-US" sz="5400" b="1" dirty="0">
                 <a:solidFill>
@@ -1164,7 +955,7 @@
             <a:endParaRPr lang="en-US" sz="5400" dirty="0"/>
           </a:p>
           <a:p>
-            <a:pPr algn="r" indent="0" marL="0">
+            <a:pPr marL="0" indent="0" algn="r">
               <a:buNone/>
             </a:pPr>
             <a:r>
@@ -1178,9 +969,6 @@
               </a:rPr>
               <a:t>Students:  </a:t>
             </a:r>
-            <a:pPr algn="r" indent="0" marL="0">
-              <a:buNone/>
-            </a:pPr>
             <a:r>
               <a:rPr lang="en-US" sz="5400" b="1" dirty="0">
                 <a:solidFill>
@@ -1204,7 +992,7 @@
         </p:nvSpPr>
         <p:spPr>
           <a:xfrm>
-            <a:off x="640080" y="5303520"/>
+            <a:off x="640080" y="4811154"/>
             <a:ext cx="23919790" cy="960120"/>
           </a:xfrm>
           <a:prstGeom prst="rect">
@@ -1220,6 +1008,13 @@
             <a:prstDash val="solid"/>
           </a:ln>
         </p:spPr>
+        <p:txBody>
+          <a:bodyPr/>
+          <a:lstStyle/>
+          <a:p>
+            <a:endParaRPr lang="he-IL"/>
+          </a:p>
+        </p:txBody>
       </p:sp>
       <p:sp>
         <p:nvSpPr>
@@ -1245,6 +1040,13 @@
             <a:prstDash val="solid"/>
           </a:ln>
         </p:spPr>
+        <p:txBody>
+          <a:bodyPr/>
+          <a:lstStyle/>
+          <a:p>
+            <a:endParaRPr lang="he-IL"/>
+          </a:p>
+        </p:txBody>
       </p:sp>
       <p:sp>
         <p:nvSpPr>
@@ -1254,7 +1056,7 @@
         </p:nvSpPr>
         <p:spPr>
           <a:xfrm>
-            <a:off x="1051560" y="5303520"/>
+            <a:off x="1097280" y="4832842"/>
             <a:ext cx="23462590" cy="960120"/>
           </a:xfrm>
           <a:prstGeom prst="rect">
@@ -1267,7 +1069,7 @@
           <a:bodyPr wrap="square" lIns="0" tIns="0" rIns="0" bIns="0" rtlCol="0" anchor="ctr"/>
           <a:lstStyle/>
           <a:p>
-            <a:pPr algn="l" indent="0" marL="0">
+            <a:pPr marL="0" indent="0" algn="l">
               <a:buNone/>
             </a:pPr>
             <a:r>
@@ -1293,8 +1095,8 @@
         </p:nvSpPr>
         <p:spPr>
           <a:xfrm>
-            <a:off x="640080" y="6355080"/>
-            <a:ext cx="23919790" cy="4754880"/>
+            <a:off x="640080" y="5862714"/>
+            <a:ext cx="23919790" cy="5795886"/>
           </a:xfrm>
           <a:prstGeom prst="rect">
             <a:avLst/>
@@ -1309,13 +1111,20 @@
             <a:prstDash val="solid"/>
           </a:ln>
           <a:effectLst>
-            <a:outerShdw sx="100000" sy="100000" kx="0" ky="0" algn="bl" rotWithShape="0" blurRad="101600" dist="25400" dir="5400000">
+            <a:outerShdw blurRad="101600" dist="25400" dir="5400000" algn="bl" rotWithShape="0">
               <a:srgbClr val="000000">
                 <a:alpha val="6000"/>
               </a:srgbClr>
             </a:outerShdw>
           </a:effectLst>
         </p:spPr>
+        <p:txBody>
+          <a:bodyPr/>
+          <a:lstStyle/>
+          <a:p>
+            <a:endParaRPr lang="he-IL" dirty="0"/>
+          </a:p>
+        </p:txBody>
       </p:sp>
       <p:sp>
         <p:nvSpPr>
@@ -1325,7 +1134,7 @@
         </p:nvSpPr>
         <p:spPr>
           <a:xfrm>
-            <a:off x="1097280" y="6675120"/>
+            <a:off x="1097280" y="5760726"/>
             <a:ext cx="23005390" cy="4114800"/>
           </a:xfrm>
           <a:prstGeom prst="rect">
@@ -1338,7 +1147,7 @@
           <a:bodyPr wrap="square" rtlCol="0" anchor="t"/>
           <a:lstStyle/>
           <a:p>
-            <a:pPr algn="l" indent="0" marL="0">
+            <a:pPr marL="0" indent="0" algn="l">
               <a:spcAft>
                 <a:spcPts val="600"/>
               </a:spcAft>
@@ -1355,14 +1164,28 @@
               </a:rPr>
               <a:t>The problem.  </a:t>
             </a:r>
-            <a:pPr algn="l" indent="0" marL="0">
+            <a:r>
+              <a:rPr lang="en-US" sz="3400" dirty="0">
+                <a:solidFill>
+                  <a:srgbClr val="0F172A"/>
+                </a:solidFill>
+                <a:latin typeface="Calibri" pitchFamily="34" charset="0"/>
+                <a:ea typeface="Calibri" pitchFamily="34" charset="-122"/>
+                <a:cs typeface="Calibri" pitchFamily="34" charset="-120"/>
+              </a:rPr>
+              <a:t>Tier-1 SOC analysts face two compounding failures: alert fatigue (thousands of events per day, most are noise) and a context gap (raw telemetry is not yet mapped to MITRE ATT&amp;CK techniques or recommended responses). The result is genuine intrusions dismissed as noise, a documented failure mode in major breaches.</a:t>
+            </a:r>
+            <a:endParaRPr lang="en-US" sz="3400" dirty="0"/>
+          </a:p>
+          <a:p>
+            <a:pPr marL="0" indent="0" algn="l">
               <a:spcAft>
                 <a:spcPts val="600"/>
               </a:spcAft>
               <a:buNone/>
             </a:pPr>
             <a:r>
-              <a:rPr lang="en-US" sz="3400" dirty="0">
+              <a:rPr lang="en-US" sz="1200" dirty="0">
                 <a:solidFill>
                   <a:srgbClr val="0F172A"/>
                 </a:solidFill>
@@ -1370,19 +1193,19 @@
                 <a:ea typeface="Calibri" pitchFamily="34" charset="-122"/>
                 <a:cs typeface="Calibri" pitchFamily="34" charset="-120"/>
               </a:rPr>
-              <a:t>Tier-1 SOC analysts face two compounding failures: alert fatigue (thousands of events per day, most are noise) and a context gap (raw telemetry is not yet mapped to MITRE ATT&amp;CK techniques or recommended responses). The result is genuine intrusions dismissed as noise, a documented failure mode in major breaches.</a:t>
+              <a:t> </a:t>
             </a:r>
             <a:endParaRPr lang="en-US" sz="3400" dirty="0"/>
           </a:p>
           <a:p>
-            <a:pPr algn="l" indent="0" marL="0">
+            <a:pPr marL="0" indent="0" algn="l">
               <a:spcAft>
                 <a:spcPts val="600"/>
               </a:spcAft>
               <a:buNone/>
             </a:pPr>
             <a:r>
-              <a:rPr lang="en-US" sz="1200" dirty="0">
+              <a:rPr lang="en-US" sz="3400" b="1" dirty="0">
                 <a:solidFill>
                   <a:srgbClr val="0F172A"/>
                 </a:solidFill>
@@ -1390,19 +1213,30 @@
                 <a:ea typeface="Calibri" pitchFamily="34" charset="-122"/>
                 <a:cs typeface="Calibri" pitchFamily="34" charset="-120"/>
               </a:rPr>
-              <a:t> </a:t>
+              <a:t>Rationale.  </a:t>
+            </a:r>
+            <a:r>
+              <a:rPr lang="en-US" sz="3400" dirty="0">
+                <a:solidFill>
+                  <a:srgbClr val="0F172A"/>
+                </a:solidFill>
+                <a:latin typeface="Calibri" pitchFamily="34" charset="0"/>
+                <a:ea typeface="Calibri" pitchFamily="34" charset="-122"/>
+                <a:cs typeface="Calibri" pitchFamily="34" charset="-120"/>
+              </a:rPr>
+              <a:t>Combine three components, each with a sharp job: an unsupervised anomaly detector for cheap detection, a deterministic rule-based mapper for auditable MITRE attribution, and a constrained LLM agent for analyst-friendly explanation. The LLM never sees raw threat-intel data, so it cannot invent technique IDs.</a:t>
             </a:r>
             <a:endParaRPr lang="en-US" sz="3400" dirty="0"/>
           </a:p>
           <a:p>
-            <a:pPr algn="l" indent="0" marL="0">
+            <a:pPr marL="0" indent="0" algn="l">
               <a:spcAft>
                 <a:spcPts val="600"/>
               </a:spcAft>
               <a:buNone/>
             </a:pPr>
             <a:r>
-              <a:rPr lang="en-US" sz="3400" b="1" dirty="0">
+              <a:rPr lang="en-US" sz="1200" dirty="0">
                 <a:solidFill>
                   <a:srgbClr val="0F172A"/>
                 </a:solidFill>
@@ -1410,15 +1244,29 @@
                 <a:ea typeface="Calibri" pitchFamily="34" charset="-122"/>
                 <a:cs typeface="Calibri" pitchFamily="34" charset="-120"/>
               </a:rPr>
-              <a:t>Rationale.  </a:t>
-            </a:r>
-            <a:pPr algn="l" indent="0" marL="0">
+              <a:t> </a:t>
+            </a:r>
+            <a:endParaRPr lang="en-US" sz="3400" dirty="0"/>
+          </a:p>
+          <a:p>
+            <a:pPr marL="0" indent="0" algn="l">
               <a:spcAft>
                 <a:spcPts val="600"/>
               </a:spcAft>
               <a:buNone/>
             </a:pPr>
             <a:r>
+              <a:rPr lang="en-US" sz="3400" b="1" dirty="0">
+                <a:solidFill>
+                  <a:srgbClr val="0F172A"/>
+                </a:solidFill>
+                <a:latin typeface="Calibri" pitchFamily="34" charset="0"/>
+                <a:ea typeface="Calibri" pitchFamily="34" charset="-122"/>
+                <a:cs typeface="Calibri" pitchFamily="34" charset="-120"/>
+              </a:rPr>
+              <a:t>Goals &amp; objectives.  </a:t>
+            </a:r>
+            <a:r>
               <a:rPr lang="en-US" sz="3400" dirty="0">
                 <a:solidFill>
                   <a:srgbClr val="0F172A"/>
@@ -1427,67 +1275,10 @@
                 <a:ea typeface="Calibri" pitchFamily="34" charset="-122"/>
                 <a:cs typeface="Calibri" pitchFamily="34" charset="-120"/>
               </a:rPr>
-              <a:t>Combine three components, each with a sharp job: an unsupervised anomaly detector for cheap detection, a deterministic rule-based mapper for auditable MITRE attribution, and a constrained LLM agent for analyst-friendly explanation. The LLM never sees raw threat-intel data, so it cannot invent technique IDs.</a:t>
+              <a:t>(1) Train an Isolation Forest on benign-only authentication events; (2) build a rule-based MITRE mapper covering T1110.001, T1110.003 and T1078; (3) integrate an AG2 LLM agent that summarises every alert in plain English, grounded in the mapper output; (4) expose the system via Chainlit with a persistent audit trail; (5) evaluate detection on held-out data and on four scripted adversarial scenarios.</a:t>
             </a:r>
             <a:endParaRPr lang="en-US" sz="3400" dirty="0"/>
           </a:p>
-          <a:p>
-            <a:pPr algn="l" indent="0" marL="0">
-              <a:spcAft>
-                <a:spcPts val="600"/>
-              </a:spcAft>
-              <a:buNone/>
-            </a:pPr>
-            <a:r>
-              <a:rPr lang="en-US" sz="1200" dirty="0">
-                <a:solidFill>
-                  <a:srgbClr val="0F172A"/>
-                </a:solidFill>
-                <a:latin typeface="Calibri" pitchFamily="34" charset="0"/>
-                <a:ea typeface="Calibri" pitchFamily="34" charset="-122"/>
-                <a:cs typeface="Calibri" pitchFamily="34" charset="-120"/>
-              </a:rPr>
-              <a:t> </a:t>
-            </a:r>
-            <a:endParaRPr lang="en-US" sz="3400" dirty="0"/>
-          </a:p>
-          <a:p>
-            <a:pPr algn="l" indent="0" marL="0">
-              <a:spcAft>
-                <a:spcPts val="600"/>
-              </a:spcAft>
-              <a:buNone/>
-            </a:pPr>
-            <a:r>
-              <a:rPr lang="en-US" sz="3400" b="1" dirty="0">
-                <a:solidFill>
-                  <a:srgbClr val="0F172A"/>
-                </a:solidFill>
-                <a:latin typeface="Calibri" pitchFamily="34" charset="0"/>
-                <a:ea typeface="Calibri" pitchFamily="34" charset="-122"/>
-                <a:cs typeface="Calibri" pitchFamily="34" charset="-120"/>
-              </a:rPr>
-              <a:t>Goals &amp; objectives.  </a:t>
-            </a:r>
-            <a:pPr algn="l" indent="0" marL="0">
-              <a:spcAft>
-                <a:spcPts val="600"/>
-              </a:spcAft>
-              <a:buNone/>
-            </a:pPr>
-            <a:r>
-              <a:rPr lang="en-US" sz="3400" dirty="0">
-                <a:solidFill>
-                  <a:srgbClr val="0F172A"/>
-                </a:solidFill>
-                <a:latin typeface="Calibri" pitchFamily="34" charset="0"/>
-                <a:ea typeface="Calibri" pitchFamily="34" charset="-122"/>
-                <a:cs typeface="Calibri" pitchFamily="34" charset="-120"/>
-              </a:rPr>
-              <a:t>(1) Train an Isolation Forest on benign-only authentication events; (2) build a rule-based MITRE mapper covering T1110.001, T1110.003 and T1078; (3) integrate an AG2 LLM agent that summarises every alert in plain English, grounded in the mapper output; (4) expose the system via Chainlit with a persistent audit trail; (5) evaluate detection on held-out data and on four scripted adversarial scenarios.</a:t>
-            </a:r>
-            <a:endParaRPr lang="en-US" sz="3400" dirty="0"/>
-          </a:p>
         </p:txBody>
       </p:sp>
       <p:sp>
@@ -1498,7 +1289,7 @@
         </p:nvSpPr>
         <p:spPr>
           <a:xfrm>
-            <a:off x="640080" y="11658600"/>
+            <a:off x="640080" y="11822722"/>
             <a:ext cx="11731295" cy="960120"/>
           </a:xfrm>
           <a:prstGeom prst="rect">
@@ -1514,6 +1305,13 @@
             <a:prstDash val="solid"/>
           </a:ln>
         </p:spPr>
+        <p:txBody>
+          <a:bodyPr/>
+          <a:lstStyle/>
+          <a:p>
+            <a:endParaRPr lang="he-IL"/>
+          </a:p>
+        </p:txBody>
       </p:sp>
       <p:sp>
         <p:nvSpPr>
@@ -1539,6 +1337,13 @@
             <a:prstDash val="solid"/>
           </a:ln>
         </p:spPr>
+        <p:txBody>
+          <a:bodyPr/>
+          <a:lstStyle/>
+          <a:p>
+            <a:endParaRPr lang="he-IL"/>
+          </a:p>
+        </p:txBody>
       </p:sp>
       <p:sp>
         <p:nvSpPr>
@@ -1548,7 +1353,7 @@
         </p:nvSpPr>
         <p:spPr>
           <a:xfrm>
-            <a:off x="1051560" y="11658600"/>
+            <a:off x="1051560" y="11775830"/>
             <a:ext cx="11274095" cy="960120"/>
           </a:xfrm>
           <a:prstGeom prst="rect">
@@ -1561,7 +1366,7 @@
           <a:bodyPr wrap="square" lIns="0" tIns="0" rIns="0" bIns="0" rtlCol="0" anchor="ctr"/>
           <a:lstStyle/>
           <a:p>
-            <a:pPr algn="l" indent="0" marL="0">
+            <a:pPr marL="0" indent="0" algn="l">
               <a:buNone/>
             </a:pPr>
             <a:r>
@@ -1587,7 +1392,7 @@
         </p:nvSpPr>
         <p:spPr>
           <a:xfrm>
-            <a:off x="640080" y="12710160"/>
+            <a:off x="640080" y="12921174"/>
             <a:ext cx="11731295" cy="9464040"/>
           </a:xfrm>
           <a:prstGeom prst="rect">
@@ -1603,13 +1408,20 @@
             <a:prstDash val="solid"/>
           </a:ln>
           <a:effectLst>
-            <a:outerShdw sx="100000" sy="100000" kx="0" ky="0" algn="bl" rotWithShape="0" blurRad="101600" dist="25400" dir="5400000">
+            <a:outerShdw blurRad="101600" dist="25400" dir="5400000" algn="bl" rotWithShape="0">
               <a:srgbClr val="000000">
                 <a:alpha val="6000"/>
               </a:srgbClr>
             </a:outerShdw>
           </a:effectLst>
         </p:spPr>
+        <p:txBody>
+          <a:bodyPr/>
+          <a:lstStyle/>
+          <a:p>
+            <a:endParaRPr lang="he-IL"/>
+          </a:p>
+        </p:txBody>
       </p:sp>
       <p:sp>
         <p:nvSpPr>
@@ -1635,6 +1447,13 @@
             <a:prstDash val="solid"/>
           </a:ln>
         </p:spPr>
+        <p:txBody>
+          <a:bodyPr/>
+          <a:lstStyle/>
+          <a:p>
+            <a:endParaRPr lang="he-IL"/>
+          </a:p>
+        </p:txBody>
       </p:sp>
       <p:sp>
         <p:nvSpPr>
@@ -1657,7 +1476,7 @@
           <a:bodyPr wrap="square" lIns="0" tIns="0" rIns="0" bIns="0" rtlCol="0" anchor="ctr"/>
           <a:lstStyle/>
           <a:p>
-            <a:pPr algn="l" indent="0" marL="0">
+            <a:pPr marL="0" indent="0" algn="l">
               <a:buNone/>
             </a:pPr>
             <a:r>
@@ -1674,7 +1493,7 @@
             <a:endParaRPr lang="en-US" sz="3400" dirty="0"/>
           </a:p>
           <a:p>
-            <a:pPr algn="l" indent="0" marL="0">
+            <a:pPr marL="0" indent="0" algn="l">
               <a:buNone/>
             </a:pPr>
             <a:r>
@@ -1716,6 +1535,13 @@
             <a:prstDash val="solid"/>
           </a:ln>
         </p:spPr>
+        <p:txBody>
+          <a:bodyPr/>
+          <a:lstStyle/>
+          <a:p>
+            <a:endParaRPr lang="he-IL"/>
+          </a:p>
+        </p:txBody>
       </p:sp>
       <p:sp>
         <p:nvSpPr>
@@ -1741,6 +1567,13 @@
             <a:prstDash val="solid"/>
           </a:ln>
         </p:spPr>
+        <p:txBody>
+          <a:bodyPr/>
+          <a:lstStyle/>
+          <a:p>
+            <a:endParaRPr lang="he-IL"/>
+          </a:p>
+        </p:txBody>
       </p:sp>
       <p:sp>
         <p:nvSpPr>
@@ -1763,7 +1596,7 @@
           <a:bodyPr wrap="square" lIns="0" tIns="0" rIns="0" bIns="0" rtlCol="0" anchor="ctr"/>
           <a:lstStyle/>
           <a:p>
-            <a:pPr algn="l" indent="0" marL="0">
+            <a:pPr marL="0" indent="0" algn="l">
               <a:buNone/>
             </a:pPr>
             <a:r>
@@ -1780,7 +1613,7 @@
             <a:endParaRPr lang="en-US" sz="3400" dirty="0"/>
           </a:p>
           <a:p>
-            <a:pPr algn="l" indent="0" marL="0">
+            <a:pPr marL="0" indent="0" algn="l">
               <a:buNone/>
             </a:pPr>
             <a:r>
@@ -1822,6 +1655,13 @@
             <a:prstDash val="solid"/>
           </a:ln>
         </p:spPr>
+        <p:txBody>
+          <a:bodyPr/>
+          <a:lstStyle/>
+          <a:p>
+            <a:endParaRPr lang="he-IL"/>
+          </a:p>
+        </p:txBody>
       </p:sp>
       <p:sp>
         <p:nvSpPr>
@@ -1847,6 +1687,13 @@
             <a:prstDash val="solid"/>
           </a:ln>
         </p:spPr>
+        <p:txBody>
+          <a:bodyPr/>
+          <a:lstStyle/>
+          <a:p>
+            <a:endParaRPr lang="he-IL"/>
+          </a:p>
+        </p:txBody>
       </p:sp>
       <p:sp>
         <p:nvSpPr>
@@ -1869,7 +1716,7 @@
           <a:bodyPr wrap="square" lIns="0" tIns="0" rIns="0" bIns="0" rtlCol="0" anchor="ctr"/>
           <a:lstStyle/>
           <a:p>
-            <a:pPr algn="l" indent="0" marL="0">
+            <a:pPr marL="0" indent="0" algn="l">
               <a:buNone/>
             </a:pPr>
             <a:r>
@@ -1886,7 +1733,7 @@
             <a:endParaRPr lang="en-US" sz="3400" dirty="0"/>
           </a:p>
           <a:p>
-            <a:pPr algn="l" indent="0" marL="0">
+            <a:pPr marL="0" indent="0" algn="l">
               <a:buNone/>
             </a:pPr>
             <a:r>
@@ -1928,6 +1775,13 @@
             <a:prstDash val="solid"/>
           </a:ln>
         </p:spPr>
+        <p:txBody>
+          <a:bodyPr/>
+          <a:lstStyle/>
+          <a:p>
+            <a:endParaRPr lang="he-IL"/>
+          </a:p>
+        </p:txBody>
       </p:sp>
       <p:sp>
         <p:nvSpPr>
@@ -1953,6 +1807,13 @@
             <a:prstDash val="solid"/>
           </a:ln>
         </p:spPr>
+        <p:txBody>
+          <a:bodyPr/>
+          <a:lstStyle/>
+          <a:p>
+            <a:endParaRPr lang="he-IL"/>
+          </a:p>
+        </p:txBody>
       </p:sp>
       <p:sp>
         <p:nvSpPr>
@@ -1975,7 +1836,7 @@
           <a:bodyPr wrap="square" lIns="0" tIns="0" rIns="0" bIns="0" rtlCol="0" anchor="ctr"/>
           <a:lstStyle/>
           <a:p>
-            <a:pPr algn="l" indent="0" marL="0">
+            <a:pPr marL="0" indent="0" algn="l">
               <a:buNone/>
             </a:pPr>
             <a:r>
@@ -1992,7 +1853,7 @@
             <a:endParaRPr lang="en-US" sz="3400" dirty="0"/>
           </a:p>
           <a:p>
-            <a:pPr algn="l" indent="0" marL="0">
+            <a:pPr marL="0" indent="0" algn="l">
               <a:buNone/>
             </a:pPr>
             <a:r>
@@ -2034,6 +1895,13 @@
             <a:prstDash val="solid"/>
           </a:ln>
         </p:spPr>
+        <p:txBody>
+          <a:bodyPr/>
+          <a:lstStyle/>
+          <a:p>
+            <a:endParaRPr lang="he-IL"/>
+          </a:p>
+        </p:txBody>
       </p:sp>
       <p:sp>
         <p:nvSpPr>
@@ -2059,6 +1927,13 @@
             <a:prstDash val="solid"/>
           </a:ln>
         </p:spPr>
+        <p:txBody>
+          <a:bodyPr/>
+          <a:lstStyle/>
+          <a:p>
+            <a:endParaRPr lang="he-IL"/>
+          </a:p>
+        </p:txBody>
       </p:sp>
       <p:sp>
         <p:nvSpPr>
@@ -2081,7 +1956,7 @@
           <a:bodyPr wrap="square" lIns="0" tIns="0" rIns="0" bIns="0" rtlCol="0" anchor="ctr"/>
           <a:lstStyle/>
           <a:p>
-            <a:pPr algn="l" indent="0" marL="0">
+            <a:pPr marL="0" indent="0" algn="l">
               <a:buNone/>
             </a:pPr>
             <a:r>
@@ -2098,7 +1973,7 @@
             <a:endParaRPr lang="en-US" sz="3400" dirty="0"/>
           </a:p>
           <a:p>
-            <a:pPr algn="l" indent="0" marL="0">
+            <a:pPr marL="0" indent="0" algn="l">
               <a:buNone/>
             </a:pPr>
             <a:r>
@@ -2124,7 +1999,7 @@
         </p:nvSpPr>
         <p:spPr>
           <a:xfrm>
-            <a:off x="1188720" y="21762720"/>
+            <a:off x="1188719" y="21607974"/>
             <a:ext cx="10634015" cy="1463040"/>
           </a:xfrm>
           <a:prstGeom prst="rect">
@@ -2137,7 +2012,7 @@
           <a:bodyPr wrap="square" lIns="0" tIns="0" rIns="0" bIns="0" rtlCol="0" anchor="t"/>
           <a:lstStyle/>
           <a:p>
-            <a:pPr algn="l" indent="0" marL="0">
+            <a:pPr marL="0" indent="0" algn="l">
               <a:buNone/>
             </a:pPr>
             <a:r>
@@ -2163,7 +2038,7 @@
         </p:nvSpPr>
         <p:spPr>
           <a:xfrm>
-            <a:off x="12828575" y="11658600"/>
+            <a:off x="12828575" y="11822722"/>
             <a:ext cx="11731295" cy="960120"/>
           </a:xfrm>
           <a:prstGeom prst="rect">
@@ -2179,6 +2054,13 @@
             <a:prstDash val="solid"/>
           </a:ln>
         </p:spPr>
+        <p:txBody>
+          <a:bodyPr/>
+          <a:lstStyle/>
+          <a:p>
+            <a:endParaRPr lang="he-IL"/>
+          </a:p>
+        </p:txBody>
       </p:sp>
       <p:sp>
         <p:nvSpPr>
@@ -2204,6 +2086,13 @@
             <a:prstDash val="solid"/>
           </a:ln>
         </p:spPr>
+        <p:txBody>
+          <a:bodyPr/>
+          <a:lstStyle/>
+          <a:p>
+            <a:endParaRPr lang="he-IL"/>
+          </a:p>
+        </p:txBody>
       </p:sp>
       <p:sp>
         <p:nvSpPr>
@@ -2213,7 +2102,7 @@
         </p:nvSpPr>
         <p:spPr>
           <a:xfrm>
-            <a:off x="13240055" y="11658600"/>
+            <a:off x="13240055" y="11775830"/>
             <a:ext cx="11274095" cy="960120"/>
           </a:xfrm>
           <a:prstGeom prst="rect">
@@ -2226,7 +2115,7 @@
           <a:bodyPr wrap="square" lIns="0" tIns="0" rIns="0" bIns="0" rtlCol="0" anchor="ctr"/>
           <a:lstStyle/>
           <a:p>
-            <a:pPr algn="l" indent="0" marL="0">
+            <a:pPr marL="0" indent="0" algn="l">
               <a:buNone/>
             </a:pPr>
             <a:r>
@@ -2252,7 +2141,7 @@
         </p:nvSpPr>
         <p:spPr>
           <a:xfrm>
-            <a:off x="12828575" y="12710160"/>
+            <a:off x="12828575" y="12921174"/>
             <a:ext cx="11731295" cy="9464040"/>
           </a:xfrm>
           <a:prstGeom prst="rect">
@@ -2268,13 +2157,20 @@
             <a:prstDash val="solid"/>
           </a:ln>
           <a:effectLst>
-            <a:outerShdw sx="100000" sy="100000" kx="0" ky="0" algn="bl" rotWithShape="0" blurRad="101600" dist="25400" dir="5400000">
+            <a:outerShdw blurRad="101600" dist="25400" dir="5400000" algn="bl" rotWithShape="0">
               <a:srgbClr val="000000">
                 <a:alpha val="6000"/>
               </a:srgbClr>
             </a:outerShdw>
           </a:effectLst>
         </p:spPr>
+        <p:txBody>
+          <a:bodyPr/>
+          <a:lstStyle/>
+          <a:p>
+            <a:endParaRPr lang="he-IL"/>
+          </a:p>
+        </p:txBody>
       </p:sp>
       <p:sp>
         <p:nvSpPr>
@@ -2300,6 +2196,13 @@
             <a:prstDash val="solid"/>
           </a:ln>
         </p:spPr>
+        <p:txBody>
+          <a:bodyPr/>
+          <a:lstStyle/>
+          <a:p>
+            <a:endParaRPr lang="he-IL"/>
+          </a:p>
+        </p:txBody>
       </p:sp>
       <p:sp>
         <p:nvSpPr>
@@ -2322,7 +2225,7 @@
           <a:bodyPr wrap="square" lIns="0" tIns="0" rIns="0" bIns="0" rtlCol="0" anchor="ctr"/>
           <a:lstStyle/>
           <a:p>
-            <a:pPr algn="ctr" indent="0" marL="0">
+            <a:pPr marL="0" indent="0" algn="ctr">
               <a:buNone/>
             </a:pPr>
             <a:r>
@@ -2361,7 +2264,7 @@
           <a:bodyPr wrap="square" lIns="0" tIns="0" rIns="0" bIns="0" rtlCol="0" anchor="ctr"/>
           <a:lstStyle/>
           <a:p>
-            <a:pPr algn="ctr" indent="0" marL="0">
+            <a:pPr marL="0" indent="0" algn="ctr">
               <a:buNone/>
             </a:pPr>
             <a:r>
@@ -2403,6 +2306,13 @@
             <a:prstDash val="solid"/>
           </a:ln>
         </p:spPr>
+        <p:txBody>
+          <a:bodyPr/>
+          <a:lstStyle/>
+          <a:p>
+            <a:endParaRPr lang="he-IL"/>
+          </a:p>
+        </p:txBody>
       </p:sp>
       <p:sp>
         <p:nvSpPr>
@@ -2425,7 +2335,7 @@
           <a:bodyPr wrap="square" lIns="0" tIns="0" rIns="0" bIns="0" rtlCol="0" anchor="ctr"/>
           <a:lstStyle/>
           <a:p>
-            <a:pPr algn="ctr" indent="0" marL="0">
+            <a:pPr marL="0" indent="0" algn="ctr">
               <a:buNone/>
             </a:pPr>
             <a:r>
@@ -2464,7 +2374,7 @@
           <a:bodyPr wrap="square" lIns="0" tIns="0" rIns="0" bIns="0" rtlCol="0" anchor="ctr"/>
           <a:lstStyle/>
           <a:p>
-            <a:pPr algn="ctr" indent="0" marL="0">
+            <a:pPr marL="0" indent="0" algn="ctr">
               <a:buNone/>
             </a:pPr>
             <a:r>
@@ -2506,6 +2416,13 @@
             <a:prstDash val="solid"/>
           </a:ln>
         </p:spPr>
+        <p:txBody>
+          <a:bodyPr/>
+          <a:lstStyle/>
+          <a:p>
+            <a:endParaRPr lang="he-IL"/>
+          </a:p>
+        </p:txBody>
       </p:sp>
       <p:sp>
         <p:nvSpPr>
@@ -2528,7 +2445,7 @@
           <a:bodyPr wrap="square" lIns="0" tIns="0" rIns="0" bIns="0" rtlCol="0" anchor="ctr"/>
           <a:lstStyle/>
           <a:p>
-            <a:pPr algn="ctr" indent="0" marL="0">
+            <a:pPr marL="0" indent="0" algn="ctr">
               <a:buNone/>
             </a:pPr>
             <a:r>
@@ -2567,7 +2484,7 @@
           <a:bodyPr wrap="square" lIns="0" tIns="0" rIns="0" bIns="0" rtlCol="0" anchor="ctr"/>
           <a:lstStyle/>
           <a:p>
-            <a:pPr algn="ctr" indent="0" marL="0">
+            <a:pPr marL="0" indent="0" algn="ctr">
               <a:buNone/>
             </a:pPr>
             <a:r>
@@ -2606,7 +2523,7 @@
           <a:bodyPr wrap="square" lIns="0" tIns="0" rIns="0" bIns="0" rtlCol="0" anchor="ctr"/>
           <a:lstStyle/>
           <a:p>
-            <a:pPr algn="l" indent="0" marL="0">
+            <a:pPr marL="0" indent="0" algn="l">
               <a:buNone/>
             </a:pPr>
             <a:r>
@@ -2626,7 +2543,7 @@
       </p:sp>
       <p:graphicFrame>
         <p:nvGraphicFramePr>
-          <p:cNvPr id="2" name="Table 0"/>
+          <p:cNvPr id="47" name="Table 0"/>
           <p:cNvGraphicFramePr>
             <a:graphicFrameLocks noGrp="1"/>
           </p:cNvGraphicFramePr>
@@ -2640,16 +2557,34 @@
         </p:nvGraphicFramePr>
         <p:xfrm>
           <a:off x="13377215" y="15819120"/>
-          <a:ext cx="10634015" cy="914400"/>
+          <a:ext cx="10634014" cy="2377440"/>
         </p:xfrm>
         <a:graphic>
           <a:graphicData uri="http://schemas.openxmlformats.org/drawingml/2006/table">
             <a:tbl>
               <a:tblPr/>
               <a:tblGrid>
-                <a:gridCol w="5848708"/>
-                <a:gridCol w="1595102"/>
-                <a:gridCol w="3190204"/>
+                <a:gridCol w="5848708">
+                  <a:extLst>
+                    <a:ext uri="{9D8B030D-6E8A-4147-A177-3AD203B41FA5}">
+                      <a16:colId xmlns:a16="http://schemas.microsoft.com/office/drawing/2014/main" val="20000"/>
+                    </a:ext>
+                  </a:extLst>
+                </a:gridCol>
+                <a:gridCol w="1595102">
+                  <a:extLst>
+                    <a:ext uri="{9D8B030D-6E8A-4147-A177-3AD203B41FA5}">
+                      <a16:colId xmlns:a16="http://schemas.microsoft.com/office/drawing/2014/main" val="20001"/>
+                    </a:ext>
+                  </a:extLst>
+                </a:gridCol>
+                <a:gridCol w="3190204">
+                  <a:extLst>
+                    <a:ext uri="{9D8B030D-6E8A-4147-A177-3AD203B41FA5}">
+                      <a16:colId xmlns:a16="http://schemas.microsoft.com/office/drawing/2014/main" val="20002"/>
+                    </a:ext>
+                  </a:extLst>
+                </a:gridCol>
               </a:tblGrid>
               <a:tr h="594360">
                 <a:tc>
@@ -2657,7 +2592,7 @@
                     <a:bodyPr/>
                     <a:lstStyle/>
                     <a:p>
-                      <a:pPr algn="l" indent="0" marL="0">
+                      <a:pPr marL="0" indent="0" algn="l">
                         <a:buNone/>
                       </a:pPr>
                       <a:r>
@@ -2678,7 +2613,7 @@
                       </a:endParaRPr>
                     </a:p>
                   </a:txBody>
-                  <a:tcPr marL="91440" marR="91440" marT="45720" marB="45720" anchor="ctr">
+                  <a:tcPr anchor="ctr">
                     <a:lnL w="12700" cap="flat" cmpd="sng" algn="ctr">
                       <a:solidFill>
                         <a:srgbClr val="E2E8F0"/>
@@ -2725,7 +2660,7 @@
                     <a:bodyPr/>
                     <a:lstStyle/>
                     <a:p>
-                      <a:pPr algn="r" indent="0" marL="0">
+                      <a:pPr marL="0" indent="0" algn="r">
                         <a:buNone/>
                       </a:pPr>
                       <a:r>
@@ -2746,7 +2681,7 @@
                       </a:endParaRPr>
                     </a:p>
                   </a:txBody>
-                  <a:tcPr marL="91440" marR="91440" marT="45720" marB="45720" anchor="ctr">
+                  <a:tcPr anchor="ctr">
                     <a:lnL w="12700" cap="flat" cmpd="sng" algn="ctr">
                       <a:solidFill>
                         <a:srgbClr val="E2E8F0"/>
@@ -2793,7 +2728,7 @@
                     <a:bodyPr/>
                     <a:lstStyle/>
                     <a:p>
-                      <a:pPr algn="r" indent="0" marL="0">
+                      <a:pPr marL="0" indent="0" algn="r">
                         <a:buNone/>
                       </a:pPr>
                       <a:r>
@@ -2814,7 +2749,7 @@
                       </a:endParaRPr>
                     </a:p>
                   </a:txBody>
-                  <a:tcPr marL="91440" marR="91440" marT="45720" marB="45720" anchor="ctr">
+                  <a:tcPr anchor="ctr">
                     <a:lnL w="12700" cap="flat" cmpd="sng" algn="ctr">
                       <a:solidFill>
                         <a:srgbClr val="E2E8F0"/>
@@ -2856,6 +2791,11 @@
                     </a:solidFill>
                   </a:tcPr>
                 </a:tc>
+                <a:extLst>
+                  <a:ext uri="{0D108BD9-81ED-4DB2-BD59-A6C34878D82A}">
+                    <a16:rowId xmlns:a16="http://schemas.microsoft.com/office/drawing/2014/main" val="10000"/>
+                  </a:ext>
+                </a:extLst>
               </a:tr>
               <a:tr h="594360">
                 <a:tc>
@@ -2863,7 +2803,7 @@
                     <a:bodyPr/>
                     <a:lstStyle/>
                     <a:p>
-                      <a:pPr algn="l" indent="0" marL="0">
+                      <a:pPr marL="0" indent="0" algn="l">
                         <a:buNone/>
                       </a:pPr>
                       <a:r>
@@ -2884,7 +2824,7 @@
                       </a:endParaRPr>
                     </a:p>
                   </a:txBody>
-                  <a:tcPr marL="91440" marR="91440" marT="45720" marB="45720" anchor="ctr">
+                  <a:tcPr anchor="ctr">
                     <a:lnL w="12700" cap="flat" cmpd="sng" algn="ctr">
                       <a:solidFill>
                         <a:srgbClr val="E2E8F0"/>
@@ -2928,7 +2868,7 @@
                     <a:bodyPr/>
                     <a:lstStyle/>
                     <a:p>
-                      <a:pPr algn="r" indent="0" marL="0">
+                      <a:pPr marL="0" indent="0" algn="r">
                         <a:buNone/>
                       </a:pPr>
                       <a:r>
@@ -2949,7 +2889,7 @@
                       </a:endParaRPr>
                     </a:p>
                   </a:txBody>
-                  <a:tcPr marL="91440" marR="91440" marT="45720" marB="45720" anchor="ctr">
+                  <a:tcPr anchor="ctr">
                     <a:lnL w="12700" cap="flat" cmpd="sng" algn="ctr">
                       <a:solidFill>
                         <a:srgbClr val="E2E8F0"/>
@@ -2993,7 +2933,7 @@
                     <a:bodyPr/>
                     <a:lstStyle/>
                     <a:p>
-                      <a:pPr algn="r" indent="0" marL="0">
+                      <a:pPr marL="0" indent="0" algn="r">
                         <a:buNone/>
                       </a:pPr>
                       <a:r>
@@ -3014,7 +2954,7 @@
                       </a:endParaRPr>
                     </a:p>
                   </a:txBody>
-                  <a:tcPr marL="91440" marR="91440" marT="45720" marB="45720" anchor="ctr">
+                  <a:tcPr anchor="ctr">
                     <a:lnL w="12700" cap="flat" cmpd="sng" algn="ctr">
                       <a:solidFill>
                         <a:srgbClr val="E2E8F0"/>
@@ -3053,6 +2993,11 @@
                     </a:lnB>
                   </a:tcPr>
                 </a:tc>
+                <a:extLst>
+                  <a:ext uri="{0D108BD9-81ED-4DB2-BD59-A6C34878D82A}">
+                    <a16:rowId xmlns:a16="http://schemas.microsoft.com/office/drawing/2014/main" val="10001"/>
+                  </a:ext>
+                </a:extLst>
               </a:tr>
               <a:tr h="594360">
                 <a:tc>
@@ -3060,7 +3005,7 @@
                     <a:bodyPr/>
                     <a:lstStyle/>
                     <a:p>
-                      <a:pPr algn="l" indent="0" marL="0">
+                      <a:pPr marL="0" indent="0" algn="l">
                         <a:buNone/>
                       </a:pPr>
                       <a:r>
@@ -3081,7 +3026,7 @@
                       </a:endParaRPr>
                     </a:p>
                   </a:txBody>
-                  <a:tcPr marL="91440" marR="91440" marT="45720" marB="45720" anchor="ctr">
+                  <a:tcPr anchor="ctr">
                     <a:lnL w="12700" cap="flat" cmpd="sng" algn="ctr">
                       <a:solidFill>
                         <a:srgbClr val="E2E8F0"/>
@@ -3125,7 +3070,7 @@
                     <a:bodyPr/>
                     <a:lstStyle/>
                     <a:p>
-                      <a:pPr algn="r" indent="0" marL="0">
+                      <a:pPr marL="0" indent="0" algn="r">
                         <a:buNone/>
                       </a:pPr>
                       <a:r>
@@ -3146,7 +3091,7 @@
                       </a:endParaRPr>
                     </a:p>
                   </a:txBody>
-                  <a:tcPr marL="91440" marR="91440" marT="45720" marB="45720" anchor="ctr">
+                  <a:tcPr anchor="ctr">
                     <a:lnL w="12700" cap="flat" cmpd="sng" algn="ctr">
                       <a:solidFill>
                         <a:srgbClr val="E2E8F0"/>
@@ -3190,7 +3135,7 @@
                     <a:bodyPr/>
                     <a:lstStyle/>
                     <a:p>
-                      <a:pPr algn="r" indent="0" marL="0">
+                      <a:pPr marL="0" indent="0" algn="r">
                         <a:buNone/>
                       </a:pPr>
                       <a:r>
@@ -3211,7 +3156,7 @@
                       </a:endParaRPr>
                     </a:p>
                   </a:txBody>
-                  <a:tcPr marL="91440" marR="91440" marT="45720" marB="45720" anchor="ctr">
+                  <a:tcPr anchor="ctr">
                     <a:lnL w="12700" cap="flat" cmpd="sng" algn="ctr">
                       <a:solidFill>
                         <a:srgbClr val="E2E8F0"/>
@@ -3250,6 +3195,11 @@
                     </a:lnB>
                   </a:tcPr>
                 </a:tc>
+                <a:extLst>
+                  <a:ext uri="{0D108BD9-81ED-4DB2-BD59-A6C34878D82A}">
+                    <a16:rowId xmlns:a16="http://schemas.microsoft.com/office/drawing/2014/main" val="10002"/>
+                  </a:ext>
+                </a:extLst>
               </a:tr>
               <a:tr h="594360">
                 <a:tc>
@@ -3257,7 +3207,7 @@
                     <a:bodyPr/>
                     <a:lstStyle/>
                     <a:p>
-                      <a:pPr algn="l" indent="0" marL="0">
+                      <a:pPr marL="0" indent="0" algn="l">
                         <a:buNone/>
                       </a:pPr>
                       <a:r>
@@ -3278,7 +3228,7 @@
                       </a:endParaRPr>
                     </a:p>
                   </a:txBody>
-                  <a:tcPr marL="91440" marR="91440" marT="45720" marB="45720" anchor="ctr">
+                  <a:tcPr anchor="ctr">
                     <a:lnL w="12700" cap="flat" cmpd="sng" algn="ctr">
                       <a:solidFill>
                         <a:srgbClr val="E2E8F0"/>
@@ -3322,7 +3272,7 @@
                     <a:bodyPr/>
                     <a:lstStyle/>
                     <a:p>
-                      <a:pPr algn="r" indent="0" marL="0">
+                      <a:pPr marL="0" indent="0" algn="r">
                         <a:buNone/>
                       </a:pPr>
                       <a:r>
@@ -3343,7 +3293,7 @@
                       </a:endParaRPr>
                     </a:p>
                   </a:txBody>
-                  <a:tcPr marL="91440" marR="91440" marT="45720" marB="45720" anchor="ctr">
+                  <a:tcPr anchor="ctr">
                     <a:lnL w="12700" cap="flat" cmpd="sng" algn="ctr">
                       <a:solidFill>
                         <a:srgbClr val="E2E8F0"/>
@@ -3387,7 +3337,7 @@
                     <a:bodyPr/>
                     <a:lstStyle/>
                     <a:p>
-                      <a:pPr algn="r" indent="0" marL="0">
+                      <a:pPr marL="0" indent="0" algn="r">
                         <a:buNone/>
                       </a:pPr>
                       <a:r>
@@ -3408,7 +3358,7 @@
                       </a:endParaRPr>
                     </a:p>
                   </a:txBody>
-                  <a:tcPr marL="91440" marR="91440" marT="45720" marB="45720" anchor="ctr">
+                  <a:tcPr anchor="ctr">
                     <a:lnL w="12700" cap="flat" cmpd="sng" algn="ctr">
                       <a:solidFill>
                         <a:srgbClr val="E2E8F0"/>
@@ -3447,6 +3397,11 @@
                     </a:lnB>
                   </a:tcPr>
                 </a:tc>
+                <a:extLst>
+                  <a:ext uri="{0D108BD9-81ED-4DB2-BD59-A6C34878D82A}">
+                    <a16:rowId xmlns:a16="http://schemas.microsoft.com/office/drawing/2014/main" val="10003"/>
+                  </a:ext>
+                </a:extLst>
               </a:tr>
             </a:tbl>
           </a:graphicData>
@@ -3473,7 +3428,7 @@
           <a:bodyPr wrap="square" lIns="0" tIns="0" rIns="0" bIns="0" rtlCol="0" anchor="t"/>
           <a:lstStyle/>
           <a:p>
-            <a:pPr algn="l" indent="0" marL="0">
+            <a:pPr marL="0" indent="0" algn="l">
               <a:buNone/>
             </a:pPr>
             <a:r>
@@ -3487,9 +3442,6 @@
               </a:rPr>
               <a:t>Adversarial scenarios.  </a:t>
             </a:r>
-            <a:pPr algn="l" indent="0" marL="0">
-              <a:buNone/>
-            </a:pPr>
             <a:r>
               <a:rPr lang="en-US" sz="3200" dirty="0">
                 <a:solidFill>
@@ -3501,9 +3453,6 @@
               </a:rPr>
               <a:t>Burst brute force 100 %  -  spraying 100 %  -  valid accounts 65 %  -  evasive (attacker mimics benign) </a:t>
             </a:r>
-            <a:pPr algn="l" indent="0" marL="0">
-              <a:buNone/>
-            </a:pPr>
             <a:r>
               <a:rPr lang="en-US" sz="3200" b="1" dirty="0">
                 <a:solidFill>
@@ -3515,9 +3464,6 @@
               </a:rPr>
               <a:t>0 %</a:t>
             </a:r>
-            <a:pPr algn="l" indent="0" marL="0">
-              <a:buNone/>
-            </a:pPr>
             <a:r>
               <a:rPr lang="en-US" sz="3200" dirty="0">
                 <a:solidFill>
@@ -3554,7 +3500,7 @@
           <a:bodyPr wrap="square" lIns="0" tIns="0" rIns="0" bIns="0" rtlCol="0" anchor="t"/>
           <a:lstStyle/>
           <a:p>
-            <a:pPr algn="l" indent="0" marL="0">
+            <a:pPr marL="0" indent="0" algn="l">
               <a:buNone/>
             </a:pPr>
             <a:r>
@@ -3596,6 +3542,13 @@
             <a:prstDash val="solid"/>
           </a:ln>
         </p:spPr>
+        <p:txBody>
+          <a:bodyPr/>
+          <a:lstStyle/>
+          <a:p>
+            <a:endParaRPr lang="he-IL"/>
+          </a:p>
+        </p:txBody>
       </p:sp>
       <p:sp>
         <p:nvSpPr>
@@ -3621,6 +3574,13 @@
             <a:prstDash val="solid"/>
           </a:ln>
         </p:spPr>
+        <p:txBody>
+          <a:bodyPr/>
+          <a:lstStyle/>
+          <a:p>
+            <a:endParaRPr lang="he-IL"/>
+          </a:p>
+        </p:txBody>
       </p:sp>
       <p:sp>
         <p:nvSpPr>
@@ -3643,7 +3603,7 @@
           <a:bodyPr wrap="square" lIns="0" tIns="0" rIns="0" bIns="0" rtlCol="0" anchor="ctr"/>
           <a:lstStyle/>
           <a:p>
-            <a:pPr algn="l" indent="0" marL="0">
+            <a:pPr marL="0" indent="0" algn="l">
               <a:buNone/>
             </a:pPr>
             <a:r>
@@ -3670,7 +3630,7 @@
         <p:spPr>
           <a:xfrm>
             <a:off x="640080" y="23774400"/>
-            <a:ext cx="23919790" cy="4023360"/>
+            <a:ext cx="23919790" cy="4362158"/>
           </a:xfrm>
           <a:prstGeom prst="rect">
             <a:avLst/>
@@ -3685,13 +3645,20 @@
             <a:prstDash val="solid"/>
           </a:ln>
           <a:effectLst>
-            <a:outerShdw sx="100000" sy="100000" kx="0" ky="0" algn="bl" rotWithShape="0" blurRad="101600" dist="25400" dir="5400000">
+            <a:outerShdw blurRad="101600" dist="25400" dir="5400000" algn="bl" rotWithShape="0">
               <a:srgbClr val="000000">
                 <a:alpha val="6000"/>
               </a:srgbClr>
             </a:outerShdw>
           </a:effectLst>
         </p:spPr>
+        <p:txBody>
+          <a:bodyPr/>
+          <a:lstStyle/>
+          <a:p>
+            <a:endParaRPr lang="he-IL"/>
+          </a:p>
+        </p:txBody>
       </p:sp>
       <p:sp>
         <p:nvSpPr>
@@ -3714,7 +3681,7 @@
           <a:bodyPr wrap="square" rtlCol="0" anchor="t"/>
           <a:lstStyle/>
           <a:p>
-            <a:pPr algn="l" indent="0" marL="0">
+            <a:pPr marL="0" indent="0" algn="l">
               <a:spcAft>
                 <a:spcPts val="600"/>
               </a:spcAft>
@@ -3731,14 +3698,28 @@
               </a:rPr>
               <a:t>Goals achieved.  </a:t>
             </a:r>
-            <a:pPr algn="l" indent="0" marL="0">
+            <a:r>
+              <a:rPr lang="en-US" sz="3400" dirty="0">
+                <a:solidFill>
+                  <a:srgbClr val="0F172A"/>
+                </a:solidFill>
+                <a:latin typeface="Calibri" pitchFamily="34" charset="0"/>
+                <a:ea typeface="Calibri" pitchFamily="34" charset="-122"/>
+                <a:cs typeface="Calibri" pitchFamily="34" charset="-120"/>
+              </a:rPr>
+              <a:t>All five objectives in §1 were met: trained Isolation Forest (ROC-AUC 0.996); deterministic mapper covering three MITRE techniques; AG2 triage agent grounded in mapper output (100 % faithfulness on 20-sample manual review); Chainlit MVP with JSONL audit log; quantitative evaluation on held-out data and four scripted scenarios.</a:t>
+            </a:r>
+            <a:endParaRPr lang="en-US" sz="3400" dirty="0"/>
+          </a:p>
+          <a:p>
+            <a:pPr marL="0" indent="0" algn="l">
               <a:spcAft>
                 <a:spcPts val="600"/>
               </a:spcAft>
               <a:buNone/>
             </a:pPr>
             <a:r>
-              <a:rPr lang="en-US" sz="3400" dirty="0">
+              <a:rPr lang="en-US" sz="1200" dirty="0">
                 <a:solidFill>
                   <a:srgbClr val="0F172A"/>
                 </a:solidFill>
@@ -3746,19 +3727,19 @@
                 <a:ea typeface="Calibri" pitchFamily="34" charset="-122"/>
                 <a:cs typeface="Calibri" pitchFamily="34" charset="-120"/>
               </a:rPr>
-              <a:t>All five objectives in §1 were met: trained Isolation Forest (ROC-AUC 0.996); deterministic mapper covering three MITRE techniques; AG2 triage agent grounded in mapper output (100 % faithfulness on 20-sample manual review); Chainlit MVP with JSONL audit log; quantitative evaluation on held-out data and four scripted scenarios.</a:t>
+              <a:t> </a:t>
             </a:r>
             <a:endParaRPr lang="en-US" sz="3400" dirty="0"/>
           </a:p>
           <a:p>
-            <a:pPr algn="l" indent="0" marL="0">
+            <a:pPr marL="0" indent="0" algn="l">
               <a:spcAft>
                 <a:spcPts val="600"/>
               </a:spcAft>
               <a:buNone/>
             </a:pPr>
             <a:r>
-              <a:rPr lang="en-US" sz="1200" dirty="0">
+              <a:rPr lang="en-US" sz="3400" b="1" dirty="0">
                 <a:solidFill>
                   <a:srgbClr val="0F172A"/>
                 </a:solidFill>
@@ -3766,34 +3747,8 @@
                 <a:ea typeface="Calibri" pitchFamily="34" charset="-122"/>
                 <a:cs typeface="Calibri" pitchFamily="34" charset="-120"/>
               </a:rPr>
-              <a:t> </a:t>
-            </a:r>
-            <a:endParaRPr lang="en-US" sz="3400" dirty="0"/>
-          </a:p>
-          <a:p>
-            <a:pPr algn="l" indent="0" marL="0">
-              <a:spcAft>
-                <a:spcPts val="600"/>
-              </a:spcAft>
-              <a:buNone/>
-            </a:pPr>
-            <a:r>
-              <a:rPr lang="en-US" sz="3400" b="1" dirty="0">
-                <a:solidFill>
-                  <a:srgbClr val="0F172A"/>
-                </a:solidFill>
-                <a:latin typeface="Calibri" pitchFamily="34" charset="0"/>
-                <a:ea typeface="Calibri" pitchFamily="34" charset="-122"/>
-                <a:cs typeface="Calibri" pitchFamily="34" charset="-120"/>
-              </a:rPr>
               <a:t>Compared to targets.  </a:t>
             </a:r>
-            <a:pPr algn="l" indent="0" marL="0">
-              <a:spcAft>
-                <a:spcPts val="600"/>
-              </a:spcAft>
-              <a:buNone/>
-            </a:pPr>
             <a:r>
               <a:rPr lang="en-US" sz="3400" dirty="0">
                 <a:solidFill>
@@ -3833,6 +3788,13 @@
             <a:prstDash val="solid"/>
           </a:ln>
         </p:spPr>
+        <p:txBody>
+          <a:bodyPr/>
+          <a:lstStyle/>
+          <a:p>
+            <a:endParaRPr lang="he-IL"/>
+          </a:p>
+        </p:txBody>
       </p:sp>
       <p:sp>
         <p:nvSpPr>
@@ -3858,6 +3820,13 @@
             <a:prstDash val="solid"/>
           </a:ln>
         </p:spPr>
+        <p:txBody>
+          <a:bodyPr/>
+          <a:lstStyle/>
+          <a:p>
+            <a:endParaRPr lang="he-IL"/>
+          </a:p>
+        </p:txBody>
       </p:sp>
       <p:sp>
         <p:nvSpPr>
@@ -3880,7 +3849,7 @@
           <a:bodyPr wrap="square" lIns="0" tIns="0" rIns="0" bIns="0" rtlCol="0" anchor="ctr"/>
           <a:lstStyle/>
           <a:p>
-            <a:pPr algn="l" indent="0" marL="0">
+            <a:pPr marL="0" indent="0" algn="l">
               <a:buNone/>
             </a:pPr>
             <a:r>
@@ -3906,8 +3875,8 @@
         </p:nvSpPr>
         <p:spPr>
           <a:xfrm>
-            <a:off x="640080" y="29397960"/>
-            <a:ext cx="23919790" cy="5961888"/>
+            <a:off x="640080" y="29306520"/>
+            <a:ext cx="23919790" cy="6601778"/>
           </a:xfrm>
           <a:prstGeom prst="rect">
             <a:avLst/>
@@ -3922,13 +3891,20 @@
             <a:prstDash val="solid"/>
           </a:ln>
           <a:effectLst>
-            <a:outerShdw sx="100000" sy="100000" kx="0" ky="0" algn="bl" rotWithShape="0" blurRad="101600" dist="25400" dir="5400000">
+            <a:outerShdw blurRad="101600" dist="25400" dir="5400000" algn="bl" rotWithShape="0">
               <a:srgbClr val="000000">
                 <a:alpha val="6000"/>
               </a:srgbClr>
             </a:outerShdw>
           </a:effectLst>
         </p:spPr>
+        <p:txBody>
+          <a:bodyPr/>
+          <a:lstStyle/>
+          <a:p>
+            <a:endParaRPr lang="he-IL"/>
+          </a:p>
+        </p:txBody>
       </p:sp>
       <p:sp>
         <p:nvSpPr>
@@ -3938,7 +3914,7 @@
         </p:nvSpPr>
         <p:spPr>
           <a:xfrm>
-            <a:off x="1097280" y="29718000"/>
+            <a:off x="1074420" y="29525976"/>
             <a:ext cx="17336110" cy="5321808"/>
           </a:xfrm>
           <a:prstGeom prst="rect">
@@ -3951,7 +3927,7 @@
           <a:bodyPr wrap="square" rtlCol="0" anchor="t"/>
           <a:lstStyle/>
           <a:p>
-            <a:pPr algn="l" indent="0" marL="0">
+            <a:pPr marL="0" indent="0" algn="l">
               <a:spcAft>
                 <a:spcPts val="400"/>
               </a:spcAft>
@@ -3971,7 +3947,7 @@
             <a:endParaRPr lang="en-US" sz="3400" dirty="0"/>
           </a:p>
           <a:p>
-            <a:pPr algn="l" indent="0" marL="0">
+            <a:pPr marL="0" indent="0" algn="l">
               <a:spcAft>
                 <a:spcPts val="400"/>
               </a:spcAft>
@@ -3991,7 +3967,7 @@
             <a:endParaRPr lang="en-US" sz="3400" dirty="0"/>
           </a:p>
           <a:p>
-            <a:pPr algn="l" indent="0" marL="0">
+            <a:pPr marL="0" indent="0" algn="l">
               <a:spcAft>
                 <a:spcPts val="400"/>
               </a:spcAft>
@@ -4008,14 +3984,39 @@
               </a:rPr>
               <a:t>1.  </a:t>
             </a:r>
-            <a:pPr algn="l" indent="0" marL="0">
+            <a:r>
+              <a:rPr lang="en-US" sz="3400" b="1" dirty="0">
+                <a:solidFill>
+                  <a:srgbClr val="0F172A"/>
+                </a:solidFill>
+                <a:latin typeface="Calibri" pitchFamily="34" charset="0"/>
+                <a:ea typeface="Calibri" pitchFamily="34" charset="-122"/>
+                <a:cs typeface="Calibri" pitchFamily="34" charset="-120"/>
+              </a:rPr>
+              <a:t>Cross-event correlation.  </a:t>
+            </a:r>
+            <a:r>
+              <a:rPr lang="en-US" sz="3400" dirty="0">
+                <a:solidFill>
+                  <a:srgbClr val="0F172A"/>
+                </a:solidFill>
+                <a:latin typeface="Calibri" pitchFamily="34" charset="0"/>
+                <a:ea typeface="Calibri" pitchFamily="34" charset="-122"/>
+                <a:cs typeface="Calibri" pitchFamily="34" charset="-120"/>
+              </a:rPr>
+              <a:t>The 0 % detection on the evasive T1078 scenario is the limit of per-event reasoning. Adding impossible-travel and first-time-from-this-IP-ever signals defeats the Volt-Typhoon SOHO-router playbook.</a:t>
+            </a:r>
+            <a:endParaRPr lang="en-US" sz="3400" dirty="0"/>
+          </a:p>
+          <a:p>
+            <a:pPr marL="0" indent="0" algn="l">
               <a:spcAft>
                 <a:spcPts val="400"/>
               </a:spcAft>
               <a:buNone/>
             </a:pPr>
             <a:r>
-              <a:rPr lang="en-US" sz="3400" b="1" dirty="0">
+              <a:rPr lang="en-US" sz="1200" dirty="0">
                 <a:solidFill>
                   <a:srgbClr val="0F172A"/>
                 </a:solidFill>
@@ -4023,15 +4024,40 @@
                 <a:ea typeface="Calibri" pitchFamily="34" charset="-122"/>
                 <a:cs typeface="Calibri" pitchFamily="34" charset="-120"/>
               </a:rPr>
-              <a:t>Cross-event correlation.  </a:t>
-            </a:r>
-            <a:pPr algn="l" indent="0" marL="0">
+              <a:t> </a:t>
+            </a:r>
+            <a:endParaRPr lang="en-US" sz="3400" dirty="0"/>
+          </a:p>
+          <a:p>
+            <a:pPr marL="0" indent="0" algn="l">
               <a:spcAft>
                 <a:spcPts val="400"/>
               </a:spcAft>
               <a:buNone/>
             </a:pPr>
             <a:r>
+              <a:rPr lang="en-US" sz="3400" b="1" dirty="0">
+                <a:solidFill>
+                  <a:srgbClr val="0891B2"/>
+                </a:solidFill>
+                <a:latin typeface="Calibri" pitchFamily="34" charset="0"/>
+                <a:ea typeface="Calibri" pitchFamily="34" charset="-122"/>
+                <a:cs typeface="Calibri" pitchFamily="34" charset="-120"/>
+              </a:rPr>
+              <a:t>2.  </a:t>
+            </a:r>
+            <a:r>
+              <a:rPr lang="en-US" sz="3400" b="1" dirty="0">
+                <a:solidFill>
+                  <a:srgbClr val="0F172A"/>
+                </a:solidFill>
+                <a:latin typeface="Calibri" pitchFamily="34" charset="0"/>
+                <a:ea typeface="Calibri" pitchFamily="34" charset="-122"/>
+                <a:cs typeface="Calibri" pitchFamily="34" charset="-120"/>
+              </a:rPr>
+              <a:t>Live data feed.  </a:t>
+            </a:r>
+            <a:r>
               <a:rPr lang="en-US" sz="3400" dirty="0">
                 <a:solidFill>
                   <a:srgbClr val="0F172A"/>
@@ -4040,12 +4066,12 @@
                 <a:ea typeface="Calibri" pitchFamily="34" charset="-122"/>
                 <a:cs typeface="Calibri" pitchFamily="34" charset="-120"/>
               </a:rPr>
-              <a:t>The 0 % detection on the evasive T1078 scenario is the limit of per-event reasoning. Adding impossible-travel and first-time-from-this-IP-ever signals defeats the Volt-Typhoon SOHO-router playbook.</a:t>
+              <a:t>Replace the synthetic generator with a 30-day rolling window of the customer's own auth logs and add drift monitoring on feature distributions.</a:t>
             </a:r>
             <a:endParaRPr lang="en-US" sz="3400" dirty="0"/>
           </a:p>
           <a:p>
-            <a:pPr algn="l" indent="0" marL="0">
+            <a:pPr marL="0" indent="0" algn="l">
               <a:spcAft>
                 <a:spcPts val="400"/>
               </a:spcAft>
@@ -4065,7 +4091,7 @@
             <a:endParaRPr lang="en-US" sz="3400" dirty="0"/>
           </a:p>
           <a:p>
-            <a:pPr algn="l" indent="0" marL="0">
+            <a:pPr marL="0" indent="0" algn="l">
               <a:spcAft>
                 <a:spcPts val="400"/>
               </a:spcAft>
@@ -4080,16 +4106,41 @@
                 <a:ea typeface="Calibri" pitchFamily="34" charset="-122"/>
                 <a:cs typeface="Calibri" pitchFamily="34" charset="-120"/>
               </a:rPr>
-              <a:t>2.  </a:t>
-            </a:r>
-            <a:pPr algn="l" indent="0" marL="0">
+              <a:t>3.  </a:t>
+            </a:r>
+            <a:r>
+              <a:rPr lang="en-US" sz="3400" b="1" dirty="0">
+                <a:solidFill>
+                  <a:srgbClr val="0F172A"/>
+                </a:solidFill>
+                <a:latin typeface="Calibri" pitchFamily="34" charset="0"/>
+                <a:ea typeface="Calibri" pitchFamily="34" charset="-122"/>
+                <a:cs typeface="Calibri" pitchFamily="34" charset="-120"/>
+              </a:rPr>
+              <a:t>Mapper expansion.  </a:t>
+            </a:r>
+            <a:r>
+              <a:rPr lang="en-US" sz="3400" dirty="0">
+                <a:solidFill>
+                  <a:srgbClr val="0F172A"/>
+                </a:solidFill>
+                <a:latin typeface="Calibri" pitchFamily="34" charset="0"/>
+                <a:ea typeface="Calibri" pitchFamily="34" charset="-122"/>
+                <a:cs typeface="Calibri" pitchFamily="34" charset="-120"/>
+              </a:rPr>
+              <a:t>Cover the top-20 enterprise MITRE techniques; route low-confidence cases to a retrieval-augmented LLM call grounded in STIX.</a:t>
+            </a:r>
+            <a:endParaRPr lang="en-US" sz="3400" dirty="0"/>
+          </a:p>
+          <a:p>
+            <a:pPr marL="0" indent="0" algn="l">
               <a:spcAft>
                 <a:spcPts val="400"/>
               </a:spcAft>
               <a:buNone/>
             </a:pPr>
             <a:r>
-              <a:rPr lang="en-US" sz="3400" b="1" dirty="0">
+              <a:rPr lang="en-US" sz="1200" dirty="0">
                 <a:solidFill>
                   <a:srgbClr val="0F172A"/>
                 </a:solidFill>
@@ -4097,15 +4148,40 @@
                 <a:ea typeface="Calibri" pitchFamily="34" charset="-122"/>
                 <a:cs typeface="Calibri" pitchFamily="34" charset="-120"/>
               </a:rPr>
-              <a:t>Live data feed.  </a:t>
-            </a:r>
-            <a:pPr algn="l" indent="0" marL="0">
+              <a:t> </a:t>
+            </a:r>
+            <a:endParaRPr lang="en-US" sz="3400" dirty="0"/>
+          </a:p>
+          <a:p>
+            <a:pPr marL="0" indent="0" algn="l">
               <a:spcAft>
                 <a:spcPts val="400"/>
               </a:spcAft>
               <a:buNone/>
             </a:pPr>
             <a:r>
+              <a:rPr lang="en-US" sz="3400" b="1" dirty="0">
+                <a:solidFill>
+                  <a:srgbClr val="0891B2"/>
+                </a:solidFill>
+                <a:latin typeface="Calibri" pitchFamily="34" charset="0"/>
+                <a:ea typeface="Calibri" pitchFamily="34" charset="-122"/>
+                <a:cs typeface="Calibri" pitchFamily="34" charset="-120"/>
+              </a:rPr>
+              <a:t>4.  </a:t>
+            </a:r>
+            <a:r>
+              <a:rPr lang="en-US" sz="3400" b="1" dirty="0">
+                <a:solidFill>
+                  <a:srgbClr val="0F172A"/>
+                </a:solidFill>
+                <a:latin typeface="Calibri" pitchFamily="34" charset="0"/>
+                <a:ea typeface="Calibri" pitchFamily="34" charset="-122"/>
+                <a:cs typeface="Calibri" pitchFamily="34" charset="-120"/>
+              </a:rPr>
+              <a:t>Incident grouping.  </a:t>
+            </a:r>
+            <a:r>
               <a:rPr lang="en-US" sz="3400" dirty="0">
                 <a:solidFill>
                   <a:srgbClr val="0F172A"/>
@@ -4114,158 +4190,10 @@
                 <a:ea typeface="Calibri" pitchFamily="34" charset="-122"/>
                 <a:cs typeface="Calibri" pitchFamily="34" charset="-120"/>
               </a:rPr>
-              <a:t>Replace the synthetic generator with a 30-day rolling window of the customer's own auth logs and add drift monitoring on feature distributions.</a:t>
+              <a:t>Aggregate correlated events keyed on source IP / user over a sliding window into single incidents.</a:t>
             </a:r>
             <a:endParaRPr lang="en-US" sz="3400" dirty="0"/>
           </a:p>
-          <a:p>
-            <a:pPr algn="l" indent="0" marL="0">
-              <a:spcAft>
-                <a:spcPts val="400"/>
-              </a:spcAft>
-              <a:buNone/>
-            </a:pPr>
-            <a:r>
-              <a:rPr lang="en-US" sz="1200" dirty="0">
-                <a:solidFill>
-                  <a:srgbClr val="0F172A"/>
-                </a:solidFill>
-                <a:latin typeface="Calibri" pitchFamily="34" charset="0"/>
-                <a:ea typeface="Calibri" pitchFamily="34" charset="-122"/>
-                <a:cs typeface="Calibri" pitchFamily="34" charset="-120"/>
-              </a:rPr>
-              <a:t> </a:t>
-            </a:r>
-            <a:endParaRPr lang="en-US" sz="3400" dirty="0"/>
-          </a:p>
-          <a:p>
-            <a:pPr algn="l" indent="0" marL="0">
-              <a:spcAft>
-                <a:spcPts val="400"/>
-              </a:spcAft>
-              <a:buNone/>
-            </a:pPr>
-            <a:r>
-              <a:rPr lang="en-US" sz="3400" b="1" dirty="0">
-                <a:solidFill>
-                  <a:srgbClr val="0891B2"/>
-                </a:solidFill>
-                <a:latin typeface="Calibri" pitchFamily="34" charset="0"/>
-                <a:ea typeface="Calibri" pitchFamily="34" charset="-122"/>
-                <a:cs typeface="Calibri" pitchFamily="34" charset="-120"/>
-              </a:rPr>
-              <a:t>3.  </a:t>
-            </a:r>
-            <a:pPr algn="l" indent="0" marL="0">
-              <a:spcAft>
-                <a:spcPts val="400"/>
-              </a:spcAft>
-              <a:buNone/>
-            </a:pPr>
-            <a:r>
-              <a:rPr lang="en-US" sz="3400" b="1" dirty="0">
-                <a:solidFill>
-                  <a:srgbClr val="0F172A"/>
-                </a:solidFill>
-                <a:latin typeface="Calibri" pitchFamily="34" charset="0"/>
-                <a:ea typeface="Calibri" pitchFamily="34" charset="-122"/>
-                <a:cs typeface="Calibri" pitchFamily="34" charset="-120"/>
-              </a:rPr>
-              <a:t>Mapper expansion.  </a:t>
-            </a:r>
-            <a:pPr algn="l" indent="0" marL="0">
-              <a:spcAft>
-                <a:spcPts val="400"/>
-              </a:spcAft>
-              <a:buNone/>
-            </a:pPr>
-            <a:r>
-              <a:rPr lang="en-US" sz="3400" dirty="0">
-                <a:solidFill>
-                  <a:srgbClr val="0F172A"/>
-                </a:solidFill>
-                <a:latin typeface="Calibri" pitchFamily="34" charset="0"/>
-                <a:ea typeface="Calibri" pitchFamily="34" charset="-122"/>
-                <a:cs typeface="Calibri" pitchFamily="34" charset="-120"/>
-              </a:rPr>
-              <a:t>Cover the top-20 enterprise MITRE techniques; route low-confidence cases to a retrieval-augmented LLM call grounded in STIX.</a:t>
-            </a:r>
-            <a:endParaRPr lang="en-US" sz="3400" dirty="0"/>
-          </a:p>
-          <a:p>
-            <a:pPr algn="l" indent="0" marL="0">
-              <a:spcAft>
-                <a:spcPts val="400"/>
-              </a:spcAft>
-              <a:buNone/>
-            </a:pPr>
-            <a:r>
-              <a:rPr lang="en-US" sz="1200" dirty="0">
-                <a:solidFill>
-                  <a:srgbClr val="0F172A"/>
-                </a:solidFill>
-                <a:latin typeface="Calibri" pitchFamily="34" charset="0"/>
-                <a:ea typeface="Calibri" pitchFamily="34" charset="-122"/>
-                <a:cs typeface="Calibri" pitchFamily="34" charset="-120"/>
-              </a:rPr>
-              <a:t> </a:t>
-            </a:r>
-            <a:endParaRPr lang="en-US" sz="3400" dirty="0"/>
-          </a:p>
-          <a:p>
-            <a:pPr algn="l" indent="0" marL="0">
-              <a:spcAft>
-                <a:spcPts val="400"/>
-              </a:spcAft>
-              <a:buNone/>
-            </a:pPr>
-            <a:r>
-              <a:rPr lang="en-US" sz="3400" b="1" dirty="0">
-                <a:solidFill>
-                  <a:srgbClr val="0891B2"/>
-                </a:solidFill>
-                <a:latin typeface="Calibri" pitchFamily="34" charset="0"/>
-                <a:ea typeface="Calibri" pitchFamily="34" charset="-122"/>
-                <a:cs typeface="Calibri" pitchFamily="34" charset="-120"/>
-              </a:rPr>
-              <a:t>4.  </a:t>
-            </a:r>
-            <a:pPr algn="l" indent="0" marL="0">
-              <a:spcAft>
-                <a:spcPts val="400"/>
-              </a:spcAft>
-              <a:buNone/>
-            </a:pPr>
-            <a:r>
-              <a:rPr lang="en-US" sz="3400" b="1" dirty="0">
-                <a:solidFill>
-                  <a:srgbClr val="0F172A"/>
-                </a:solidFill>
-                <a:latin typeface="Calibri" pitchFamily="34" charset="0"/>
-                <a:ea typeface="Calibri" pitchFamily="34" charset="-122"/>
-                <a:cs typeface="Calibri" pitchFamily="34" charset="-120"/>
-              </a:rPr>
-              <a:t>Incident grouping.  </a:t>
-            </a:r>
-            <a:pPr algn="l" indent="0" marL="0">
-              <a:spcAft>
-                <a:spcPts val="400"/>
-              </a:spcAft>
-              <a:buNone/>
-            </a:pPr>
-            <a:r>
-              <a:rPr lang="en-US" sz="3400" dirty="0">
-                <a:solidFill>
-                  <a:srgbClr val="0F172A"/>
-                </a:solidFill>
-                <a:latin typeface="Calibri" pitchFamily="34" charset="0"/>
-                <a:ea typeface="Calibri" pitchFamily="34" charset="-122"/>
-                <a:cs typeface="Calibri" pitchFamily="34" charset="-120"/>
-              </a:rPr>
-              <a:t>Aggregate correlated events keyed on source IP / user over a sliding window into single incidents.</a:t>
-            </a:r>
-            <a:endParaRPr lang="en-US" sz="3400" dirty="0"/>
-          </a:p>
         </p:txBody>
       </p:sp>
       <p:sp>
@@ -4276,7 +4204,7 @@
         </p:nvSpPr>
         <p:spPr>
           <a:xfrm>
-            <a:off x="18524830" y="29809440"/>
+            <a:off x="18524829" y="29306520"/>
             <a:ext cx="5486400" cy="5047488"/>
           </a:xfrm>
           <a:prstGeom prst="rect">
@@ -4292,6 +4220,13 @@
             <a:prstDash val="solid"/>
           </a:ln>
         </p:spPr>
+        <p:txBody>
+          <a:bodyPr/>
+          <a:lstStyle/>
+          <a:p>
+            <a:endParaRPr lang="he-IL"/>
+          </a:p>
+        </p:txBody>
       </p:sp>
       <p:sp>
         <p:nvSpPr>
@@ -4317,6 +4252,13 @@
             <a:prstDash val="solid"/>
           </a:ln>
         </p:spPr>
+        <p:txBody>
+          <a:bodyPr/>
+          <a:lstStyle/>
+          <a:p>
+            <a:endParaRPr lang="he-IL"/>
+          </a:p>
+        </p:txBody>
       </p:sp>
       <p:sp>
         <p:nvSpPr>
@@ -4326,7 +4268,7 @@
         </p:nvSpPr>
         <p:spPr>
           <a:xfrm>
-            <a:off x="18799150" y="30129480"/>
+            <a:off x="18399710" y="29208537"/>
             <a:ext cx="4937760" cy="640080"/>
           </a:xfrm>
           <a:prstGeom prst="rect">
@@ -4339,7 +4281,7 @@
           <a:bodyPr wrap="square" lIns="0" tIns="0" rIns="0" bIns="0" rtlCol="0" anchor="ctr"/>
           <a:lstStyle/>
           <a:p>
-            <a:pPr algn="ctr" indent="0" marL="0">
+            <a:pPr marL="0" indent="0" algn="ctr">
               <a:buNone/>
             </a:pPr>
             <a:r>
@@ -4359,1064 +4301,14 @@
       </p:sp>
       <p:sp>
         <p:nvSpPr>
-          <p:cNvPr id="63" name="Shape 60"/>
-          <p:cNvSpPr/>
-          <p:nvPr/>
-        </p:nvSpPr>
-        <p:spPr>
-          <a:xfrm>
-            <a:off x="19713550" y="30861000"/>
-            <a:ext cx="3108960" cy="3108960"/>
-          </a:xfrm>
-          <a:prstGeom prst="rect">
-            <a:avLst/>
-          </a:prstGeom>
-          <a:solidFill>
-            <a:srgbClr val="FFFFFF"/>
-          </a:solidFill>
-          <a:ln w="12700">
-            <a:solidFill>
-              <a:srgbClr val="FFFFFF"/>
-            </a:solidFill>
-            <a:prstDash val="solid"/>
-          </a:ln>
-        </p:spPr>
-      </p:sp>
-      <p:sp>
-        <p:nvSpPr>
-          <p:cNvPr id="64" name="Shape 61"/>
-          <p:cNvSpPr/>
-          <p:nvPr/>
-        </p:nvSpPr>
-        <p:spPr>
-          <a:xfrm>
-            <a:off x="19713550" y="30861000"/>
-            <a:ext cx="388620" cy="388620"/>
-          </a:xfrm>
-          <a:prstGeom prst="rect">
-            <a:avLst/>
-          </a:prstGeom>
-          <a:solidFill>
-            <a:srgbClr val="0F172A"/>
-          </a:solidFill>
-          <a:ln w="12700">
-            <a:solidFill>
-              <a:srgbClr val="0F172A"/>
-            </a:solidFill>
-            <a:prstDash val="solid"/>
-          </a:ln>
-        </p:spPr>
-      </p:sp>
-      <p:sp>
-        <p:nvSpPr>
-          <p:cNvPr id="65" name="Shape 62"/>
-          <p:cNvSpPr/>
-          <p:nvPr/>
-        </p:nvSpPr>
-        <p:spPr>
-          <a:xfrm>
-            <a:off x="20490790" y="30861000"/>
-            <a:ext cx="388620" cy="388620"/>
-          </a:xfrm>
-          <a:prstGeom prst="rect">
-            <a:avLst/>
-          </a:prstGeom>
-          <a:solidFill>
-            <a:srgbClr val="0F172A"/>
-          </a:solidFill>
-          <a:ln w="12700">
-            <a:solidFill>
-              <a:srgbClr val="0F172A"/>
-            </a:solidFill>
-            <a:prstDash val="solid"/>
-          </a:ln>
-        </p:spPr>
-      </p:sp>
-      <p:sp>
-        <p:nvSpPr>
-          <p:cNvPr id="66" name="Shape 63"/>
-          <p:cNvSpPr/>
-          <p:nvPr/>
-        </p:nvSpPr>
-        <p:spPr>
-          <a:xfrm>
-            <a:off x="21268030" y="30861000"/>
-            <a:ext cx="388620" cy="388620"/>
-          </a:xfrm>
-          <a:prstGeom prst="rect">
-            <a:avLst/>
-          </a:prstGeom>
-          <a:solidFill>
-            <a:srgbClr val="0F172A"/>
-          </a:solidFill>
-          <a:ln w="12700">
-            <a:solidFill>
-              <a:srgbClr val="0F172A"/>
-            </a:solidFill>
-            <a:prstDash val="solid"/>
-          </a:ln>
-        </p:spPr>
-      </p:sp>
-      <p:sp>
-        <p:nvSpPr>
-          <p:cNvPr id="67" name="Shape 64"/>
-          <p:cNvSpPr/>
-          <p:nvPr/>
-        </p:nvSpPr>
-        <p:spPr>
-          <a:xfrm>
-            <a:off x="22045270" y="30861000"/>
-            <a:ext cx="388620" cy="388620"/>
-          </a:xfrm>
-          <a:prstGeom prst="rect">
-            <a:avLst/>
-          </a:prstGeom>
-          <a:solidFill>
-            <a:srgbClr val="0F172A"/>
-          </a:solidFill>
-          <a:ln w="12700">
-            <a:solidFill>
-              <a:srgbClr val="0F172A"/>
-            </a:solidFill>
-            <a:prstDash val="solid"/>
-          </a:ln>
-        </p:spPr>
-      </p:sp>
-      <p:sp>
-        <p:nvSpPr>
-          <p:cNvPr id="68" name="Shape 65"/>
-          <p:cNvSpPr/>
-          <p:nvPr/>
-        </p:nvSpPr>
-        <p:spPr>
-          <a:xfrm>
-            <a:off x="20102170" y="31249620"/>
-            <a:ext cx="388620" cy="388620"/>
-          </a:xfrm>
-          <a:prstGeom prst="rect">
-            <a:avLst/>
-          </a:prstGeom>
-          <a:solidFill>
-            <a:srgbClr val="0F172A"/>
-          </a:solidFill>
-          <a:ln w="12700">
-            <a:solidFill>
-              <a:srgbClr val="0F172A"/>
-            </a:solidFill>
-            <a:prstDash val="solid"/>
-          </a:ln>
-        </p:spPr>
-      </p:sp>
-      <p:sp>
-        <p:nvSpPr>
-          <p:cNvPr id="69" name="Shape 66"/>
-          <p:cNvSpPr/>
-          <p:nvPr/>
-        </p:nvSpPr>
-        <p:spPr>
-          <a:xfrm>
-            <a:off x="20879410" y="31249620"/>
-            <a:ext cx="388620" cy="388620"/>
-          </a:xfrm>
-          <a:prstGeom prst="rect">
-            <a:avLst/>
-          </a:prstGeom>
-          <a:solidFill>
-            <a:srgbClr val="0F172A"/>
-          </a:solidFill>
-          <a:ln w="12700">
-            <a:solidFill>
-              <a:srgbClr val="0F172A"/>
-            </a:solidFill>
-            <a:prstDash val="solid"/>
-          </a:ln>
-        </p:spPr>
-      </p:sp>
-      <p:sp>
-        <p:nvSpPr>
-          <p:cNvPr id="70" name="Shape 67"/>
-          <p:cNvSpPr/>
-          <p:nvPr/>
-        </p:nvSpPr>
-        <p:spPr>
-          <a:xfrm>
-            <a:off x="21656650" y="31249620"/>
-            <a:ext cx="388620" cy="388620"/>
-          </a:xfrm>
-          <a:prstGeom prst="rect">
-            <a:avLst/>
-          </a:prstGeom>
-          <a:solidFill>
-            <a:srgbClr val="0F172A"/>
-          </a:solidFill>
-          <a:ln w="12700">
-            <a:solidFill>
-              <a:srgbClr val="0F172A"/>
-            </a:solidFill>
-            <a:prstDash val="solid"/>
-          </a:ln>
-        </p:spPr>
-      </p:sp>
-      <p:sp>
-        <p:nvSpPr>
-          <p:cNvPr id="71" name="Shape 68"/>
-          <p:cNvSpPr/>
-          <p:nvPr/>
-        </p:nvSpPr>
-        <p:spPr>
-          <a:xfrm>
-            <a:off x="22433890" y="31249620"/>
-            <a:ext cx="388620" cy="388620"/>
-          </a:xfrm>
-          <a:prstGeom prst="rect">
-            <a:avLst/>
-          </a:prstGeom>
-          <a:solidFill>
-            <a:srgbClr val="0F172A"/>
-          </a:solidFill>
-          <a:ln w="12700">
-            <a:solidFill>
-              <a:srgbClr val="0F172A"/>
-            </a:solidFill>
-            <a:prstDash val="solid"/>
-          </a:ln>
-        </p:spPr>
-      </p:sp>
-      <p:sp>
-        <p:nvSpPr>
-          <p:cNvPr id="72" name="Shape 69"/>
-          <p:cNvSpPr/>
-          <p:nvPr/>
-        </p:nvSpPr>
-        <p:spPr>
-          <a:xfrm>
-            <a:off x="19713550" y="31638240"/>
-            <a:ext cx="388620" cy="388620"/>
-          </a:xfrm>
-          <a:prstGeom prst="rect">
-            <a:avLst/>
-          </a:prstGeom>
-          <a:solidFill>
-            <a:srgbClr val="0F172A"/>
-          </a:solidFill>
-          <a:ln w="12700">
-            <a:solidFill>
-              <a:srgbClr val="0F172A"/>
-            </a:solidFill>
-            <a:prstDash val="solid"/>
-          </a:ln>
-        </p:spPr>
-      </p:sp>
-      <p:sp>
-        <p:nvSpPr>
-          <p:cNvPr id="73" name="Shape 70"/>
-          <p:cNvSpPr/>
-          <p:nvPr/>
-        </p:nvSpPr>
-        <p:spPr>
-          <a:xfrm>
-            <a:off x="20490790" y="31638240"/>
-            <a:ext cx="388620" cy="388620"/>
-          </a:xfrm>
-          <a:prstGeom prst="rect">
-            <a:avLst/>
-          </a:prstGeom>
-          <a:solidFill>
-            <a:srgbClr val="0F172A"/>
-          </a:solidFill>
-          <a:ln w="12700">
-            <a:solidFill>
-              <a:srgbClr val="0F172A"/>
-            </a:solidFill>
-            <a:prstDash val="solid"/>
-          </a:ln>
-        </p:spPr>
-      </p:sp>
-      <p:sp>
-        <p:nvSpPr>
-          <p:cNvPr id="74" name="Shape 71"/>
-          <p:cNvSpPr/>
-          <p:nvPr/>
-        </p:nvSpPr>
-        <p:spPr>
-          <a:xfrm>
-            <a:off x="21268030" y="31638240"/>
-            <a:ext cx="388620" cy="388620"/>
-          </a:xfrm>
-          <a:prstGeom prst="rect">
-            <a:avLst/>
-          </a:prstGeom>
-          <a:solidFill>
-            <a:srgbClr val="0F172A"/>
-          </a:solidFill>
-          <a:ln w="12700">
-            <a:solidFill>
-              <a:srgbClr val="0F172A"/>
-            </a:solidFill>
-            <a:prstDash val="solid"/>
-          </a:ln>
-        </p:spPr>
-      </p:sp>
-      <p:sp>
-        <p:nvSpPr>
-          <p:cNvPr id="75" name="Shape 72"/>
-          <p:cNvSpPr/>
-          <p:nvPr/>
-        </p:nvSpPr>
-        <p:spPr>
-          <a:xfrm>
-            <a:off x="22045270" y="31638240"/>
-            <a:ext cx="388620" cy="388620"/>
-          </a:xfrm>
-          <a:prstGeom prst="rect">
-            <a:avLst/>
-          </a:prstGeom>
-          <a:solidFill>
-            <a:srgbClr val="0F172A"/>
-          </a:solidFill>
-          <a:ln w="12700">
-            <a:solidFill>
-              <a:srgbClr val="0F172A"/>
-            </a:solidFill>
-            <a:prstDash val="solid"/>
-          </a:ln>
-        </p:spPr>
-      </p:sp>
-      <p:sp>
-        <p:nvSpPr>
-          <p:cNvPr id="76" name="Shape 73"/>
-          <p:cNvSpPr/>
-          <p:nvPr/>
-        </p:nvSpPr>
-        <p:spPr>
-          <a:xfrm>
-            <a:off x="20102170" y="32026860"/>
-            <a:ext cx="388620" cy="388620"/>
-          </a:xfrm>
-          <a:prstGeom prst="rect">
-            <a:avLst/>
-          </a:prstGeom>
-          <a:solidFill>
-            <a:srgbClr val="0F172A"/>
-          </a:solidFill>
-          <a:ln w="12700">
-            <a:solidFill>
-              <a:srgbClr val="0F172A"/>
-            </a:solidFill>
-            <a:prstDash val="solid"/>
-          </a:ln>
-        </p:spPr>
-      </p:sp>
-      <p:sp>
-        <p:nvSpPr>
-          <p:cNvPr id="77" name="Shape 74"/>
-          <p:cNvSpPr/>
-          <p:nvPr/>
-        </p:nvSpPr>
-        <p:spPr>
-          <a:xfrm>
-            <a:off x="20879410" y="32026860"/>
-            <a:ext cx="388620" cy="388620"/>
-          </a:xfrm>
-          <a:prstGeom prst="rect">
-            <a:avLst/>
-          </a:prstGeom>
-          <a:solidFill>
-            <a:srgbClr val="0F172A"/>
-          </a:solidFill>
-          <a:ln w="12700">
-            <a:solidFill>
-              <a:srgbClr val="0F172A"/>
-            </a:solidFill>
-            <a:prstDash val="solid"/>
-          </a:ln>
-        </p:spPr>
-      </p:sp>
-      <p:sp>
-        <p:nvSpPr>
-          <p:cNvPr id="78" name="Shape 75"/>
-          <p:cNvSpPr/>
-          <p:nvPr/>
-        </p:nvSpPr>
-        <p:spPr>
-          <a:xfrm>
-            <a:off x="21656650" y="32026860"/>
-            <a:ext cx="388620" cy="388620"/>
-          </a:xfrm>
-          <a:prstGeom prst="rect">
-            <a:avLst/>
-          </a:prstGeom>
-          <a:solidFill>
-            <a:srgbClr val="0F172A"/>
-          </a:solidFill>
-          <a:ln w="12700">
-            <a:solidFill>
-              <a:srgbClr val="0F172A"/>
-            </a:solidFill>
-            <a:prstDash val="solid"/>
-          </a:ln>
-        </p:spPr>
-      </p:sp>
-      <p:sp>
-        <p:nvSpPr>
-          <p:cNvPr id="79" name="Shape 76"/>
-          <p:cNvSpPr/>
-          <p:nvPr/>
-        </p:nvSpPr>
-        <p:spPr>
-          <a:xfrm>
-            <a:off x="22433890" y="32026860"/>
-            <a:ext cx="388620" cy="388620"/>
-          </a:xfrm>
-          <a:prstGeom prst="rect">
-            <a:avLst/>
-          </a:prstGeom>
-          <a:solidFill>
-            <a:srgbClr val="0F172A"/>
-          </a:solidFill>
-          <a:ln w="12700">
-            <a:solidFill>
-              <a:srgbClr val="0F172A"/>
-            </a:solidFill>
-            <a:prstDash val="solid"/>
-          </a:ln>
-        </p:spPr>
-      </p:sp>
-      <p:sp>
-        <p:nvSpPr>
-          <p:cNvPr id="80" name="Shape 77"/>
-          <p:cNvSpPr/>
-          <p:nvPr/>
-        </p:nvSpPr>
-        <p:spPr>
-          <a:xfrm>
-            <a:off x="19713550" y="32415480"/>
-            <a:ext cx="388620" cy="388620"/>
-          </a:xfrm>
-          <a:prstGeom prst="rect">
-            <a:avLst/>
-          </a:prstGeom>
-          <a:solidFill>
-            <a:srgbClr val="0F172A"/>
-          </a:solidFill>
-          <a:ln w="12700">
-            <a:solidFill>
-              <a:srgbClr val="0F172A"/>
-            </a:solidFill>
-            <a:prstDash val="solid"/>
-          </a:ln>
-        </p:spPr>
-      </p:sp>
-      <p:sp>
-        <p:nvSpPr>
-          <p:cNvPr id="81" name="Shape 78"/>
-          <p:cNvSpPr/>
-          <p:nvPr/>
-        </p:nvSpPr>
-        <p:spPr>
-          <a:xfrm>
-            <a:off x="20490790" y="32415480"/>
-            <a:ext cx="388620" cy="388620"/>
-          </a:xfrm>
-          <a:prstGeom prst="rect">
-            <a:avLst/>
-          </a:prstGeom>
-          <a:solidFill>
-            <a:srgbClr val="0F172A"/>
-          </a:solidFill>
-          <a:ln w="12700">
-            <a:solidFill>
-              <a:srgbClr val="0F172A"/>
-            </a:solidFill>
-            <a:prstDash val="solid"/>
-          </a:ln>
-        </p:spPr>
-      </p:sp>
-      <p:sp>
-        <p:nvSpPr>
-          <p:cNvPr id="82" name="Shape 79"/>
-          <p:cNvSpPr/>
-          <p:nvPr/>
-        </p:nvSpPr>
-        <p:spPr>
-          <a:xfrm>
-            <a:off x="21268030" y="32415480"/>
-            <a:ext cx="388620" cy="388620"/>
-          </a:xfrm>
-          <a:prstGeom prst="rect">
-            <a:avLst/>
-          </a:prstGeom>
-          <a:solidFill>
-            <a:srgbClr val="0F172A"/>
-          </a:solidFill>
-          <a:ln w="12700">
-            <a:solidFill>
-              <a:srgbClr val="0F172A"/>
-            </a:solidFill>
-            <a:prstDash val="solid"/>
-          </a:ln>
-        </p:spPr>
-      </p:sp>
-      <p:sp>
-        <p:nvSpPr>
-          <p:cNvPr id="83" name="Shape 80"/>
-          <p:cNvSpPr/>
-          <p:nvPr/>
-        </p:nvSpPr>
-        <p:spPr>
-          <a:xfrm>
-            <a:off x="22045270" y="32415480"/>
-            <a:ext cx="388620" cy="388620"/>
-          </a:xfrm>
-          <a:prstGeom prst="rect">
-            <a:avLst/>
-          </a:prstGeom>
-          <a:solidFill>
-            <a:srgbClr val="0F172A"/>
-          </a:solidFill>
-          <a:ln w="12700">
-            <a:solidFill>
-              <a:srgbClr val="0F172A"/>
-            </a:solidFill>
-            <a:prstDash val="solid"/>
-          </a:ln>
-        </p:spPr>
-      </p:sp>
-      <p:sp>
-        <p:nvSpPr>
-          <p:cNvPr id="84" name="Shape 81"/>
-          <p:cNvSpPr/>
-          <p:nvPr/>
-        </p:nvSpPr>
-        <p:spPr>
-          <a:xfrm>
-            <a:off x="20102170" y="32804100"/>
-            <a:ext cx="388620" cy="388620"/>
-          </a:xfrm>
-          <a:prstGeom prst="rect">
-            <a:avLst/>
-          </a:prstGeom>
-          <a:solidFill>
-            <a:srgbClr val="0F172A"/>
-          </a:solidFill>
-          <a:ln w="12700">
-            <a:solidFill>
-              <a:srgbClr val="0F172A"/>
-            </a:solidFill>
-            <a:prstDash val="solid"/>
-          </a:ln>
-        </p:spPr>
-      </p:sp>
-      <p:sp>
-        <p:nvSpPr>
-          <p:cNvPr id="85" name="Shape 82"/>
-          <p:cNvSpPr/>
-          <p:nvPr/>
-        </p:nvSpPr>
-        <p:spPr>
-          <a:xfrm>
-            <a:off x="20879410" y="32804100"/>
-            <a:ext cx="388620" cy="388620"/>
-          </a:xfrm>
-          <a:prstGeom prst="rect">
-            <a:avLst/>
-          </a:prstGeom>
-          <a:solidFill>
-            <a:srgbClr val="0F172A"/>
-          </a:solidFill>
-          <a:ln w="12700">
-            <a:solidFill>
-              <a:srgbClr val="0F172A"/>
-            </a:solidFill>
-            <a:prstDash val="solid"/>
-          </a:ln>
-        </p:spPr>
-      </p:sp>
-      <p:sp>
-        <p:nvSpPr>
-          <p:cNvPr id="86" name="Shape 83"/>
-          <p:cNvSpPr/>
-          <p:nvPr/>
-        </p:nvSpPr>
-        <p:spPr>
-          <a:xfrm>
-            <a:off x="21656650" y="32804100"/>
-            <a:ext cx="388620" cy="388620"/>
-          </a:xfrm>
-          <a:prstGeom prst="rect">
-            <a:avLst/>
-          </a:prstGeom>
-          <a:solidFill>
-            <a:srgbClr val="0F172A"/>
-          </a:solidFill>
-          <a:ln w="12700">
-            <a:solidFill>
-              <a:srgbClr val="0F172A"/>
-            </a:solidFill>
-            <a:prstDash val="solid"/>
-          </a:ln>
-        </p:spPr>
-      </p:sp>
-      <p:sp>
-        <p:nvSpPr>
-          <p:cNvPr id="87" name="Shape 84"/>
-          <p:cNvSpPr/>
-          <p:nvPr/>
-        </p:nvSpPr>
-        <p:spPr>
-          <a:xfrm>
-            <a:off x="22433890" y="32804100"/>
-            <a:ext cx="388620" cy="388620"/>
-          </a:xfrm>
-          <a:prstGeom prst="rect">
-            <a:avLst/>
-          </a:prstGeom>
-          <a:solidFill>
-            <a:srgbClr val="0F172A"/>
-          </a:solidFill>
-          <a:ln w="12700">
-            <a:solidFill>
-              <a:srgbClr val="0F172A"/>
-            </a:solidFill>
-            <a:prstDash val="solid"/>
-          </a:ln>
-        </p:spPr>
-      </p:sp>
-      <p:sp>
-        <p:nvSpPr>
-          <p:cNvPr id="88" name="Shape 85"/>
-          <p:cNvSpPr/>
-          <p:nvPr/>
-        </p:nvSpPr>
-        <p:spPr>
-          <a:xfrm>
-            <a:off x="19713550" y="33192720"/>
-            <a:ext cx="388620" cy="388620"/>
-          </a:xfrm>
-          <a:prstGeom prst="rect">
-            <a:avLst/>
-          </a:prstGeom>
-          <a:solidFill>
-            <a:srgbClr val="0F172A"/>
-          </a:solidFill>
-          <a:ln w="12700">
-            <a:solidFill>
-              <a:srgbClr val="0F172A"/>
-            </a:solidFill>
-            <a:prstDash val="solid"/>
-          </a:ln>
-        </p:spPr>
-      </p:sp>
-      <p:sp>
-        <p:nvSpPr>
-          <p:cNvPr id="89" name="Shape 86"/>
-          <p:cNvSpPr/>
-          <p:nvPr/>
-        </p:nvSpPr>
-        <p:spPr>
-          <a:xfrm>
-            <a:off x="20490790" y="33192720"/>
-            <a:ext cx="388620" cy="388620"/>
-          </a:xfrm>
-          <a:prstGeom prst="rect">
-            <a:avLst/>
-          </a:prstGeom>
-          <a:solidFill>
-            <a:srgbClr val="0F172A"/>
-          </a:solidFill>
-          <a:ln w="12700">
-            <a:solidFill>
-              <a:srgbClr val="0F172A"/>
-            </a:solidFill>
-            <a:prstDash val="solid"/>
-          </a:ln>
-        </p:spPr>
-      </p:sp>
-      <p:sp>
-        <p:nvSpPr>
-          <p:cNvPr id="90" name="Shape 87"/>
-          <p:cNvSpPr/>
-          <p:nvPr/>
-        </p:nvSpPr>
-        <p:spPr>
-          <a:xfrm>
-            <a:off x="21268030" y="33192720"/>
-            <a:ext cx="388620" cy="388620"/>
-          </a:xfrm>
-          <a:prstGeom prst="rect">
-            <a:avLst/>
-          </a:prstGeom>
-          <a:solidFill>
-            <a:srgbClr val="0F172A"/>
-          </a:solidFill>
-          <a:ln w="12700">
-            <a:solidFill>
-              <a:srgbClr val="0F172A"/>
-            </a:solidFill>
-            <a:prstDash val="solid"/>
-          </a:ln>
-        </p:spPr>
-      </p:sp>
-      <p:sp>
-        <p:nvSpPr>
-          <p:cNvPr id="91" name="Shape 88"/>
-          <p:cNvSpPr/>
-          <p:nvPr/>
-        </p:nvSpPr>
-        <p:spPr>
-          <a:xfrm>
-            <a:off x="22045270" y="33192720"/>
-            <a:ext cx="388620" cy="388620"/>
-          </a:xfrm>
-          <a:prstGeom prst="rect">
-            <a:avLst/>
-          </a:prstGeom>
-          <a:solidFill>
-            <a:srgbClr val="0F172A"/>
-          </a:solidFill>
-          <a:ln w="12700">
-            <a:solidFill>
-              <a:srgbClr val="0F172A"/>
-            </a:solidFill>
-            <a:prstDash val="solid"/>
-          </a:ln>
-        </p:spPr>
-      </p:sp>
-      <p:sp>
-        <p:nvSpPr>
-          <p:cNvPr id="92" name="Shape 89"/>
-          <p:cNvSpPr/>
-          <p:nvPr/>
-        </p:nvSpPr>
-        <p:spPr>
-          <a:xfrm>
-            <a:off x="20102170" y="33581340"/>
-            <a:ext cx="388620" cy="388620"/>
-          </a:xfrm>
-          <a:prstGeom prst="rect">
-            <a:avLst/>
-          </a:prstGeom>
-          <a:solidFill>
-            <a:srgbClr val="0F172A"/>
-          </a:solidFill>
-          <a:ln w="12700">
-            <a:solidFill>
-              <a:srgbClr val="0F172A"/>
-            </a:solidFill>
-            <a:prstDash val="solid"/>
-          </a:ln>
-        </p:spPr>
-      </p:sp>
-      <p:sp>
-        <p:nvSpPr>
-          <p:cNvPr id="93" name="Shape 90"/>
-          <p:cNvSpPr/>
-          <p:nvPr/>
-        </p:nvSpPr>
-        <p:spPr>
-          <a:xfrm>
-            <a:off x="20879410" y="33581340"/>
-            <a:ext cx="388620" cy="388620"/>
-          </a:xfrm>
-          <a:prstGeom prst="rect">
-            <a:avLst/>
-          </a:prstGeom>
-          <a:solidFill>
-            <a:srgbClr val="0F172A"/>
-          </a:solidFill>
-          <a:ln w="12700">
-            <a:solidFill>
-              <a:srgbClr val="0F172A"/>
-            </a:solidFill>
-            <a:prstDash val="solid"/>
-          </a:ln>
-        </p:spPr>
-      </p:sp>
-      <p:sp>
-        <p:nvSpPr>
-          <p:cNvPr id="94" name="Shape 91"/>
-          <p:cNvSpPr/>
-          <p:nvPr/>
-        </p:nvSpPr>
-        <p:spPr>
-          <a:xfrm>
-            <a:off x="21656650" y="33581340"/>
-            <a:ext cx="388620" cy="388620"/>
-          </a:xfrm>
-          <a:prstGeom prst="rect">
-            <a:avLst/>
-          </a:prstGeom>
-          <a:solidFill>
-            <a:srgbClr val="0F172A"/>
-          </a:solidFill>
-          <a:ln w="12700">
-            <a:solidFill>
-              <a:srgbClr val="0F172A"/>
-            </a:solidFill>
-            <a:prstDash val="solid"/>
-          </a:ln>
-        </p:spPr>
-      </p:sp>
-      <p:sp>
-        <p:nvSpPr>
-          <p:cNvPr id="95" name="Shape 92"/>
-          <p:cNvSpPr/>
-          <p:nvPr/>
-        </p:nvSpPr>
-        <p:spPr>
-          <a:xfrm>
-            <a:off x="22433890" y="33581340"/>
-            <a:ext cx="388620" cy="388620"/>
-          </a:xfrm>
-          <a:prstGeom prst="rect">
-            <a:avLst/>
-          </a:prstGeom>
-          <a:solidFill>
-            <a:srgbClr val="0F172A"/>
-          </a:solidFill>
-          <a:ln w="12700">
-            <a:solidFill>
-              <a:srgbClr val="0F172A"/>
-            </a:solidFill>
-            <a:prstDash val="solid"/>
-          </a:ln>
-        </p:spPr>
-      </p:sp>
-      <p:sp>
-        <p:nvSpPr>
-          <p:cNvPr id="96" name="Shape 93"/>
-          <p:cNvSpPr/>
-          <p:nvPr/>
-        </p:nvSpPr>
-        <p:spPr>
-          <a:xfrm>
-            <a:off x="19713550" y="30861000"/>
-            <a:ext cx="1165860" cy="1165860"/>
-          </a:xfrm>
-          <a:prstGeom prst="rect">
-            <a:avLst/>
-          </a:prstGeom>
-          <a:solidFill>
-            <a:srgbClr val="0F172A"/>
-          </a:solidFill>
-          <a:ln w="12700">
-            <a:solidFill>
-              <a:srgbClr val="0F172A"/>
-            </a:solidFill>
-            <a:prstDash val="solid"/>
-          </a:ln>
-        </p:spPr>
-      </p:sp>
-      <p:sp>
-        <p:nvSpPr>
-          <p:cNvPr id="97" name="Shape 94"/>
-          <p:cNvSpPr/>
-          <p:nvPr/>
-        </p:nvSpPr>
-        <p:spPr>
-          <a:xfrm>
-            <a:off x="19907860" y="31055310"/>
-            <a:ext cx="777240" cy="777240"/>
-          </a:xfrm>
-          <a:prstGeom prst="rect">
-            <a:avLst/>
-          </a:prstGeom>
-          <a:solidFill>
-            <a:srgbClr val="FFFFFF"/>
-          </a:solidFill>
-          <a:ln w="12700">
-            <a:solidFill>
-              <a:srgbClr val="FFFFFF"/>
-            </a:solidFill>
-            <a:prstDash val="solid"/>
-          </a:ln>
-        </p:spPr>
-      </p:sp>
-      <p:sp>
-        <p:nvSpPr>
-          <p:cNvPr id="98" name="Shape 95"/>
-          <p:cNvSpPr/>
-          <p:nvPr/>
-        </p:nvSpPr>
-        <p:spPr>
-          <a:xfrm>
-            <a:off x="20102170" y="31249620"/>
-            <a:ext cx="388620" cy="388620"/>
-          </a:xfrm>
-          <a:prstGeom prst="rect">
-            <a:avLst/>
-          </a:prstGeom>
-          <a:solidFill>
-            <a:srgbClr val="0F172A"/>
-          </a:solidFill>
-          <a:ln w="12700">
-            <a:solidFill>
-              <a:srgbClr val="0F172A"/>
-            </a:solidFill>
-            <a:prstDash val="solid"/>
-          </a:ln>
-        </p:spPr>
-      </p:sp>
-      <p:sp>
-        <p:nvSpPr>
-          <p:cNvPr id="99" name="Shape 96"/>
-          <p:cNvSpPr/>
-          <p:nvPr/>
-        </p:nvSpPr>
-        <p:spPr>
-          <a:xfrm>
-            <a:off x="21656650" y="30861000"/>
-            <a:ext cx="1165860" cy="1165860"/>
-          </a:xfrm>
-          <a:prstGeom prst="rect">
-            <a:avLst/>
-          </a:prstGeom>
-          <a:solidFill>
-            <a:srgbClr val="0F172A"/>
-          </a:solidFill>
-          <a:ln w="12700">
-            <a:solidFill>
-              <a:srgbClr val="0F172A"/>
-            </a:solidFill>
-            <a:prstDash val="solid"/>
-          </a:ln>
-        </p:spPr>
-      </p:sp>
-      <p:sp>
-        <p:nvSpPr>
-          <p:cNvPr id="100" name="Shape 97"/>
-          <p:cNvSpPr/>
-          <p:nvPr/>
-        </p:nvSpPr>
-        <p:spPr>
-          <a:xfrm>
-            <a:off x="21850960" y="31055310"/>
-            <a:ext cx="777240" cy="777240"/>
-          </a:xfrm>
-          <a:prstGeom prst="rect">
-            <a:avLst/>
-          </a:prstGeom>
-          <a:solidFill>
-            <a:srgbClr val="FFFFFF"/>
-          </a:solidFill>
-          <a:ln w="12700">
-            <a:solidFill>
-              <a:srgbClr val="FFFFFF"/>
-            </a:solidFill>
-            <a:prstDash val="solid"/>
-          </a:ln>
-        </p:spPr>
-      </p:sp>
-      <p:sp>
-        <p:nvSpPr>
-          <p:cNvPr id="101" name="Shape 98"/>
-          <p:cNvSpPr/>
-          <p:nvPr/>
-        </p:nvSpPr>
-        <p:spPr>
-          <a:xfrm>
-            <a:off x="22045270" y="31249620"/>
-            <a:ext cx="388620" cy="388620"/>
-          </a:xfrm>
-          <a:prstGeom prst="rect">
-            <a:avLst/>
-          </a:prstGeom>
-          <a:solidFill>
-            <a:srgbClr val="0F172A"/>
-          </a:solidFill>
-          <a:ln w="12700">
-            <a:solidFill>
-              <a:srgbClr val="0F172A"/>
-            </a:solidFill>
-            <a:prstDash val="solid"/>
-          </a:ln>
-        </p:spPr>
-      </p:sp>
-      <p:sp>
-        <p:nvSpPr>
-          <p:cNvPr id="102" name="Shape 99"/>
-          <p:cNvSpPr/>
-          <p:nvPr/>
-        </p:nvSpPr>
-        <p:spPr>
-          <a:xfrm>
-            <a:off x="19713550" y="32804100"/>
-            <a:ext cx="1165860" cy="1165860"/>
-          </a:xfrm>
-          <a:prstGeom prst="rect">
-            <a:avLst/>
-          </a:prstGeom>
-          <a:solidFill>
-            <a:srgbClr val="0F172A"/>
-          </a:solidFill>
-          <a:ln w="12700">
-            <a:solidFill>
-              <a:srgbClr val="0F172A"/>
-            </a:solidFill>
-            <a:prstDash val="solid"/>
-          </a:ln>
-        </p:spPr>
-      </p:sp>
-      <p:sp>
-        <p:nvSpPr>
-          <p:cNvPr id="103" name="Shape 100"/>
-          <p:cNvSpPr/>
-          <p:nvPr/>
-        </p:nvSpPr>
-        <p:spPr>
-          <a:xfrm>
-            <a:off x="19907860" y="32998410"/>
-            <a:ext cx="777240" cy="777240"/>
-          </a:xfrm>
-          <a:prstGeom prst="rect">
-            <a:avLst/>
-          </a:prstGeom>
-          <a:solidFill>
-            <a:srgbClr val="FFFFFF"/>
-          </a:solidFill>
-          <a:ln w="12700">
-            <a:solidFill>
-              <a:srgbClr val="FFFFFF"/>
-            </a:solidFill>
-            <a:prstDash val="solid"/>
-          </a:ln>
-        </p:spPr>
-      </p:sp>
-      <p:sp>
-        <p:nvSpPr>
-          <p:cNvPr id="104" name="Shape 101"/>
-          <p:cNvSpPr/>
-          <p:nvPr/>
-        </p:nvSpPr>
-        <p:spPr>
-          <a:xfrm>
-            <a:off x="20102170" y="33192720"/>
-            <a:ext cx="388620" cy="388620"/>
-          </a:xfrm>
-          <a:prstGeom prst="rect">
-            <a:avLst/>
-          </a:prstGeom>
-          <a:solidFill>
-            <a:srgbClr val="0F172A"/>
-          </a:solidFill>
-          <a:ln w="12700">
-            <a:solidFill>
-              <a:srgbClr val="0F172A"/>
-            </a:solidFill>
-            <a:prstDash val="solid"/>
-          </a:ln>
-        </p:spPr>
-      </p:sp>
-      <p:sp>
-        <p:nvSpPr>
-          <p:cNvPr id="105" name="Text 102"/>
-          <p:cNvSpPr/>
-          <p:nvPr/>
-        </p:nvSpPr>
-        <p:spPr>
-          <a:xfrm>
-            <a:off x="19713550" y="34061400"/>
-            <a:ext cx="3108960" cy="365760"/>
+          <p:cNvPr id="106" name="Text 103"/>
+          <p:cNvSpPr/>
+          <p:nvPr/>
+        </p:nvSpPr>
+        <p:spPr>
+          <a:xfrm>
+            <a:off x="18671362" y="34451991"/>
+            <a:ext cx="4937760" cy="457200"/>
           </a:xfrm>
           <a:prstGeom prst="rect">
             <a:avLst/>
@@ -5428,33 +4320,33 @@
           <a:bodyPr wrap="square" lIns="0" tIns="0" rIns="0" bIns="0" rtlCol="0" anchor="ctr"/>
           <a:lstStyle/>
           <a:p>
-            <a:pPr algn="ctr" indent="0" marL="0">
-              <a:buNone/>
-            </a:pPr>
-            <a:r>
-              <a:rPr lang="en-US" sz="2200" i="1" dirty="0">
-                <a:solidFill>
-                  <a:srgbClr val="94A3B8"/>
-                </a:solidFill>
-                <a:latin typeface="Calibri" pitchFamily="34" charset="0"/>
-                <a:ea typeface="Calibri" pitchFamily="34" charset="-122"/>
-                <a:cs typeface="Calibri" pitchFamily="34" charset="-120"/>
-              </a:rPr>
-              <a:t>[ Replace with QR ]</a:t>
-            </a:r>
-            <a:endParaRPr lang="en-US" sz="2200" dirty="0"/>
-          </a:p>
-        </p:txBody>
-      </p:sp>
-      <p:sp>
-        <p:nvSpPr>
-          <p:cNvPr id="106" name="Text 103"/>
-          <p:cNvSpPr/>
-          <p:nvPr/>
-        </p:nvSpPr>
-        <p:spPr>
-          <a:xfrm>
-            <a:off x="18799150" y="34472880"/>
+            <a:pPr marL="0" indent="0" algn="ctr">
+              <a:buNone/>
+            </a:pPr>
+            <a:r>
+              <a:rPr lang="en-US" sz="3000" b="1" dirty="0">
+                <a:solidFill>
+                  <a:srgbClr val="22D3EE"/>
+                </a:solidFill>
+                <a:latin typeface="Calibri" pitchFamily="34" charset="0"/>
+                <a:ea typeface="Calibri" pitchFamily="34" charset="-122"/>
+                <a:cs typeface="Calibri" pitchFamily="34" charset="-120"/>
+              </a:rPr>
+              <a:t>Code repository</a:t>
+            </a:r>
+            <a:endParaRPr lang="en-US" sz="3000" dirty="0"/>
+          </a:p>
+        </p:txBody>
+      </p:sp>
+      <p:sp>
+        <p:nvSpPr>
+          <p:cNvPr id="107" name="Text 104"/>
+          <p:cNvSpPr/>
+          <p:nvPr/>
+        </p:nvSpPr>
+        <p:spPr>
+          <a:xfrm>
+            <a:off x="18694222" y="35062668"/>
             <a:ext cx="4937760" cy="457200"/>
           </a:xfrm>
           <a:prstGeom prst="rect">
@@ -5467,53 +4359,11 @@
           <a:bodyPr wrap="square" lIns="0" tIns="0" rIns="0" bIns="0" rtlCol="0" anchor="ctr"/>
           <a:lstStyle/>
           <a:p>
-            <a:pPr algn="ctr" indent="0" marL="0">
-              <a:buNone/>
-            </a:pPr>
-            <a:r>
-              <a:rPr lang="en-US" sz="3000" b="1" dirty="0">
-                <a:solidFill>
-                  <a:srgbClr val="22D3EE"/>
-                </a:solidFill>
-                <a:latin typeface="Calibri" pitchFamily="34" charset="0"/>
-                <a:ea typeface="Calibri" pitchFamily="34" charset="-122"/>
-                <a:cs typeface="Calibri" pitchFamily="34" charset="-120"/>
-              </a:rPr>
-              <a:t>Code repository</a:t>
-            </a:r>
-            <a:endParaRPr lang="en-US" sz="3000" dirty="0"/>
-          </a:p>
-        </p:txBody>
-      </p:sp>
-      <p:sp>
-        <p:nvSpPr>
-          <p:cNvPr id="107" name="Text 104"/>
-          <p:cNvSpPr/>
-          <p:nvPr/>
-        </p:nvSpPr>
-        <p:spPr>
-          <a:xfrm>
-            <a:off x="18799150" y="34930080"/>
-            <a:ext cx="4937760" cy="457200"/>
-          </a:xfrm>
-          <a:prstGeom prst="rect">
-            <a:avLst/>
-          </a:prstGeom>
-          <a:noFill/>
-          <a:ln/>
-        </p:spPr>
-        <p:txBody>
-          <a:bodyPr wrap="square" lIns="0" tIns="0" rIns="0" bIns="0" rtlCol="0" anchor="ctr"/>
-          <a:lstStyle/>
-          <a:p>
-            <a:pPr algn="ctr" indent="0" marL="0">
+            <a:pPr marL="0" indent="0" algn="ctr">
               <a:buNone/>
             </a:pPr>
             <a:r>
               <a:rPr lang="en-US" sz="2200" dirty="0">
-                <a:solidFill>
-                  <a:srgbClr val="FFFFFF"/>
-                </a:solidFill>
                 <a:latin typeface="Consolas" pitchFamily="34" charset="0"/>
                 <a:ea typeface="Consolas" pitchFamily="34" charset="-122"/>
                 <a:cs typeface="Consolas" pitchFamily="34" charset="-120"/>
@@ -5524,6 +4374,36 @@
           </a:p>
         </p:txBody>
       </p:sp>
+      <p:pic>
+        <p:nvPicPr>
+          <p:cNvPr id="109" name="תמונה 108">
+            <a:extLst>
+              <a:ext uri="{FF2B5EF4-FFF2-40B4-BE49-F238E27FC236}">
+                <a16:creationId xmlns:a16="http://schemas.microsoft.com/office/drawing/2014/main" id="{F3694179-EA17-D11B-ACE8-6ACC3B5B3A9D}"/>
+              </a:ext>
+            </a:extLst>
+          </p:cNvPr>
+          <p:cNvPicPr>
+            <a:picLocks noChangeAspect="1"/>
+          </p:cNvPicPr>
+          <p:nvPr/>
+        </p:nvPicPr>
+        <p:blipFill>
+          <a:blip r:embed="rId3"/>
+          <a:stretch>
+            <a:fillRect/>
+          </a:stretch>
+        </p:blipFill>
+        <p:spPr>
+          <a:xfrm>
+            <a:off x="19299697" y="30239012"/>
+            <a:ext cx="3726809" cy="3739232"/>
+          </a:xfrm>
+          <a:prstGeom prst="rect">
+            <a:avLst/>
+          </a:prstGeom>
+        </p:spPr>
+      </p:pic>
     </p:spTree>
   </p:cSld>
   <p:clrMapOvr>
@@ -5825,4 +4705,319 @@
     </a:ext>
   </a:extLst>
 </a:theme>
+</file>
+
+<file path=ppt/theme/theme2.xml><?xml version="1.0" encoding="utf-8"?>
+<a:theme xmlns:a="http://schemas.openxmlformats.org/drawingml/2006/main" name="ערכת נושא Office">
+  <a:themeElements>
+    <a:clrScheme name="Office">
+      <a:dk1>
+        <a:sysClr val="windowText" lastClr="000000"/>
+      </a:dk1>
+      <a:lt1>
+        <a:sysClr val="window" lastClr="FFFFFF"/>
+      </a:lt1>
+      <a:dk2>
+        <a:srgbClr val="0E2841"/>
+      </a:dk2>
+      <a:lt2>
+        <a:srgbClr val="E8E8E8"/>
+      </a:lt2>
+      <a:accent1>
+        <a:srgbClr val="156082"/>
+      </a:accent1>
+      <a:accent2>
+        <a:srgbClr val="E97132"/>
+      </a:accent2>
+      <a:accent3>
+        <a:srgbClr val="196B24"/>
+      </a:accent3>
+      <a:accent4>
+        <a:srgbClr val="0F9ED5"/>
+      </a:accent4>
+      <a:accent5>
+        <a:srgbClr val="A02B93"/>
+      </a:accent5>
+      <a:accent6>
+        <a:srgbClr val="4EA72E"/>
+      </a:accent6>
+      <a:hlink>
+        <a:srgbClr val="467886"/>
+      </a:hlink>
+      <a:folHlink>
+        <a:srgbClr val="96607D"/>
+      </a:folHlink>
+    </a:clrScheme>
+    <a:fontScheme name="Office">
+      <a:majorFont>
+        <a:latin typeface="Aptos Display" panose="02110004020202020204"/>
+        <a:ea typeface=""/>
+        <a:cs typeface=""/>
+        <a:font script="Jpan" typeface="游ゴシック Light"/>
+        <a:font script="Hang" typeface="맑은 고딕"/>
+        <a:font script="Hans" typeface="等线 Light"/>
+        <a:font script="Hant" typeface="新細明體"/>
+        <a:font script="Arab" typeface="Times New Roman"/>
+        <a:font script="Hebr" typeface="Times New Roman"/>
+        <a:font script="Thai" typeface="Angsana New"/>
+        <a:font script="Ethi" typeface="Nyala"/>
+        <a:font script="Beng" typeface="Vrinda"/>
+        <a:font script="Gujr" typeface="Shruti"/>
+        <a:font script="Khmr" typeface="MoolBoran"/>
+        <a:font script="Knda" typeface="Tunga"/>
+        <a:font script="Guru" typeface="Raavi"/>
+        <a:font script="Cans" typeface="Euphemia"/>
+        <a:font script="Cher" typeface="Plantagenet Cherokee"/>
+        <a:font script="Yiii" typeface="Microsoft Yi Baiti"/>
+        <a:font script="Tibt" typeface="Microsoft Himalaya"/>
+        <a:font script="Thaa" typeface="MV Boli"/>
+        <a:font script="Deva" typeface="Mangal"/>
+        <a:font script="Telu" typeface="Gautami"/>
+        <a:font script="Taml" typeface="Latha"/>
+        <a:font script="Syrc" typeface="Estrangelo Edessa"/>
+        <a:font script="Orya" typeface="Kalinga"/>
+        <a:font script="Mlym" typeface="Kartika"/>
+        <a:font script="Laoo" typeface="DokChampa"/>
+        <a:font script="Sinh" typeface="Iskoola Pota"/>
+        <a:font script="Mong" typeface="Mongolian Baiti"/>
+        <a:font script="Viet" typeface="Times New Roman"/>
+        <a:font script="Uigh" typeface="Microsoft Uighur"/>
+        <a:font script="Geor" typeface="Sylfaen"/>
+        <a:font script="Armn" typeface="Arial"/>
+        <a:font script="Bugi" typeface="Leelawadee UI"/>
+        <a:font script="Bopo" typeface="Microsoft JhengHei"/>
+        <a:font script="Java" typeface="Javanese Text"/>
+        <a:font script="Lisu" typeface="Segoe UI"/>
+        <a:font script="Mymr" typeface="Myanmar Text"/>
+        <a:font script="Nkoo" typeface="Ebrima"/>
+        <a:font script="Olck" typeface="Nirmala UI"/>
+        <a:font script="Osma" typeface="Ebrima"/>
+        <a:font script="Phag" typeface="Phagspa"/>
+        <a:font script="Syrn" typeface="Estrangelo Edessa"/>
+        <a:font script="Syrj" typeface="Estrangelo Edessa"/>
+        <a:font script="Syre" typeface="Estrangelo Edessa"/>
+        <a:font script="Sora" typeface="Nirmala UI"/>
+        <a:font script="Tale" typeface="Microsoft Tai Le"/>
+        <a:font script="Talu" typeface="Microsoft New Tai Lue"/>
+        <a:font script="Tfng" typeface="Ebrima"/>
+      </a:majorFont>
+      <a:minorFont>
+        <a:latin typeface="Aptos" panose="02110004020202020204"/>
+        <a:ea typeface=""/>
+        <a:cs typeface=""/>
+        <a:font script="Jpan" typeface="游ゴシック"/>
+        <a:font script="Hang" typeface="맑은 고딕"/>
+        <a:font script="Hans" typeface="等线"/>
+        <a:font script="Hant" typeface="新細明體"/>
+        <a:font script="Arab" typeface="Arial"/>
+        <a:font script="Hebr" typeface="Arial"/>
+        <a:font script="Thai" typeface="Cordia New"/>
+        <a:font script="Ethi" typeface="Nyala"/>
+        <a:font script="Beng" typeface="Vrinda"/>
+        <a:font script="Gujr" typeface="Shruti"/>
+        <a:font script="Khmr" typeface="DaunPenh"/>
+        <a:font script="Knda" typeface="Tunga"/>
+        <a:font script="Guru" typeface="Raavi"/>
+        <a:font script="Cans" typeface="Euphemia"/>
+        <a:font script="Cher" typeface="Plantagenet Cherokee"/>
+        <a:font script="Yiii" typeface="Microsoft Yi Baiti"/>
+        <a:font script="Tibt" typeface="Microsoft Himalaya"/>
+        <a:font script="Thaa" typeface="MV Boli"/>
+        <a:font script="Deva" typeface="Mangal"/>
+        <a:font script="Telu" typeface="Gautami"/>
+        <a:font script="Taml" typeface="Latha"/>
+        <a:font script="Syrc" typeface="Estrangelo Edessa"/>
+        <a:font script="Orya" typeface="Kalinga"/>
+        <a:font script="Mlym" typeface="Kartika"/>
+        <a:font script="Laoo" typeface="DokChampa"/>
+        <a:font script="Sinh" typeface="Iskoola Pota"/>
+        <a:font script="Mong" typeface="Mongolian Baiti"/>
+        <a:font script="Viet" typeface="Arial"/>
+        <a:font script="Uigh" typeface="Microsoft Uighur"/>
+        <a:font script="Geor" typeface="Sylfaen"/>
+        <a:font script="Armn" typeface="Arial"/>
+        <a:font script="Bugi" typeface="Leelawadee UI"/>
+        <a:font script="Bopo" typeface="Microsoft JhengHei"/>
+        <a:font script="Java" typeface="Javanese Text"/>
+        <a:font script="Lisu" typeface="Segoe UI"/>
+        <a:font script="Mymr" typeface="Myanmar Text"/>
+        <a:font script="Nkoo" typeface="Ebrima"/>
+        <a:font script="Olck" typeface="Nirmala UI"/>
+        <a:font script="Osma" typeface="Ebrima"/>
+        <a:font script="Phag" typeface="Phagspa"/>
+        <a:font script="Syrn" typeface="Estrangelo Edessa"/>
+        <a:font script="Syrj" typeface="Estrangelo Edessa"/>
+        <a:font script="Syre" typeface="Estrangelo Edessa"/>
+        <a:font script="Sora" typeface="Nirmala UI"/>
+        <a:font script="Tale" typeface="Microsoft Tai Le"/>
+        <a:font script="Talu" typeface="Microsoft New Tai Lue"/>
+        <a:font script="Tfng" typeface="Ebrima"/>
+      </a:minorFont>
+    </a:fontScheme>
+    <a:fmtScheme name="Office">
+      <a:fillStyleLst>
+        <a:solidFill>
+          <a:schemeClr val="phClr"/>
+        </a:solidFill>
+        <a:gradFill rotWithShape="1">
+          <a:gsLst>
+            <a:gs pos="0">
+              <a:schemeClr val="phClr">
+                <a:lumMod val="110000"/>
+                <a:satMod val="105000"/>
+                <a:tint val="67000"/>
+              </a:schemeClr>
+            </a:gs>
+            <a:gs pos="50000">
+              <a:schemeClr val="phClr">
+                <a:lumMod val="105000"/>
+                <a:satMod val="103000"/>
+                <a:tint val="73000"/>
+              </a:schemeClr>
+            </a:gs>
+            <a:gs pos="100000">
+              <a:schemeClr val="phClr">
+                <a:lumMod val="105000"/>
+                <a:satMod val="109000"/>
+                <a:tint val="81000"/>
+              </a:schemeClr>
+            </a:gs>
+          </a:gsLst>
+          <a:lin ang="5400000" scaled="0"/>
+        </a:gradFill>
+        <a:gradFill rotWithShape="1">
+          <a:gsLst>
+            <a:gs pos="0">
+              <a:schemeClr val="phClr">
+                <a:satMod val="103000"/>
+                <a:lumMod val="102000"/>
+                <a:tint val="94000"/>
+              </a:schemeClr>
+            </a:gs>
+            <a:gs pos="50000">
+              <a:schemeClr val="phClr">
+                <a:satMod val="110000"/>
+                <a:lumMod val="100000"/>
+                <a:shade val="100000"/>
+              </a:schemeClr>
+            </a:gs>
+            <a:gs pos="100000">
+              <a:schemeClr val="phClr">
+                <a:lumMod val="99000"/>
+                <a:satMod val="120000"/>
+                <a:shade val="78000"/>
+              </a:schemeClr>
+            </a:gs>
+          </a:gsLst>
+          <a:lin ang="5400000" scaled="0"/>
+        </a:gradFill>
+      </a:fillStyleLst>
+      <a:lnStyleLst>
+        <a:ln w="12700" cap="flat" cmpd="sng" algn="ctr">
+          <a:solidFill>
+            <a:schemeClr val="phClr"/>
+          </a:solidFill>
+          <a:prstDash val="solid"/>
+          <a:miter lim="800000"/>
+        </a:ln>
+        <a:ln w="19050" cap="flat" cmpd="sng" algn="ctr">
+          <a:solidFill>
+            <a:schemeClr val="phClr"/>
+          </a:solidFill>
+          <a:prstDash val="solid"/>
+          <a:miter lim="800000"/>
+        </a:ln>
+        <a:ln w="25400" cap="flat" cmpd="sng" algn="ctr">
+          <a:solidFill>
+            <a:schemeClr val="phClr"/>
+          </a:solidFill>
+          <a:prstDash val="solid"/>
+          <a:miter lim="800000"/>
+        </a:ln>
+      </a:lnStyleLst>
+      <a:effectStyleLst>
+        <a:effectStyle>
+          <a:effectLst/>
+        </a:effectStyle>
+        <a:effectStyle>
+          <a:effectLst/>
+        </a:effectStyle>
+        <a:effectStyle>
+          <a:effectLst>
+            <a:outerShdw blurRad="57150" dist="19050" dir="5400000" algn="ctr" rotWithShape="0">
+              <a:srgbClr val="000000">
+                <a:alpha val="63000"/>
+              </a:srgbClr>
+            </a:outerShdw>
+          </a:effectLst>
+        </a:effectStyle>
+      </a:effectStyleLst>
+      <a:bgFillStyleLst>
+        <a:solidFill>
+          <a:schemeClr val="phClr"/>
+        </a:solidFill>
+        <a:solidFill>
+          <a:schemeClr val="phClr">
+            <a:tint val="95000"/>
+            <a:satMod val="170000"/>
+          </a:schemeClr>
+        </a:solidFill>
+        <a:gradFill rotWithShape="1">
+          <a:gsLst>
+            <a:gs pos="0">
+              <a:schemeClr val="phClr">
+                <a:tint val="93000"/>
+                <a:satMod val="150000"/>
+                <a:shade val="98000"/>
+                <a:lumMod val="102000"/>
+              </a:schemeClr>
+            </a:gs>
+            <a:gs pos="50000">
+              <a:schemeClr val="phClr">
+                <a:tint val="98000"/>
+                <a:satMod val="130000"/>
+                <a:shade val="90000"/>
+                <a:lumMod val="103000"/>
+              </a:schemeClr>
+            </a:gs>
+            <a:gs pos="100000">
+              <a:schemeClr val="phClr">
+                <a:shade val="63000"/>
+                <a:satMod val="120000"/>
+              </a:schemeClr>
+            </a:gs>
+          </a:gsLst>
+          <a:lin ang="5400000" scaled="0"/>
+        </a:gradFill>
+      </a:bgFillStyleLst>
+    </a:fmtScheme>
+  </a:themeElements>
+  <a:objectDefaults>
+    <a:lnDef>
+      <a:spPr/>
+      <a:bodyPr/>
+      <a:lstStyle/>
+      <a:style>
+        <a:lnRef idx="2">
+          <a:schemeClr val="accent1"/>
+        </a:lnRef>
+        <a:fillRef idx="0">
+          <a:schemeClr val="accent1"/>
+        </a:fillRef>
+        <a:effectRef idx="1">
+          <a:schemeClr val="accent1"/>
+        </a:effectRef>
+        <a:fontRef idx="minor">
+          <a:schemeClr val="tx1"/>
+        </a:fontRef>
+      </a:style>
+    </a:lnDef>
+  </a:objectDefaults>
+  <a:extraClrSchemeLst/>
+  <a:extLst>
+    <a:ext uri="{05A4C25C-085E-4340-85A3-A5531E510DB2}">
+      <thm15:themeFamily xmlns:thm15="http://schemas.microsoft.com/office/thememl/2012/main" name="Office Theme" id="{2E142A2C-CD16-42D6-873A-C26D2A0506FA}" vid="{1BDDFF52-6CD6-40A5-AB3C-68EB2F1E4D0A}"/>
+    </a:ext>
+  </a:extLst>
+</a:theme>
 </file>
</xml_diff>